<commit_message>
Enlarge text sizes across RA briefing slides
Co-Authored-By: Claude Opus 5.5 <noreply@anthropic.com>
Claude-Session: https://claude.ai/code/session_01LZtd5ZCaickQQtidZY1i9h
</commit_message>
<xml_diff>
--- a/RA募集説明会_RAプレゼン_20261023.pptx
+++ b/RA募集説明会_RAプレゼン_20261023.pptx
@@ -112,32 +112,32 @@
   <p:extLst>
     <p:ext uri="{521415D9-36F7-43E2-AB2F-B90AF26B5E84}">
       <p14:sectionLst xmlns:p14="http://schemas.microsoft.com/office/powerpoint/2010/main">
-        <p14:section name="表紙" id="{fec1ba63-b010-a548-cf6a-636f8fab064b}">
+        <p14:section name="表紙" id="{3e2c8929-dde9-aa1b-bf4a-1eb042d4c988}">
           <p14:sldIdLst>
             <p14:sldId id="256"/>
           </p14:sldIdLst>
         </p14:section>
-        <p14:section name="年間スケジュール" id="{7a121177-97e9-07f3-5ea5-a61042f03f2d}">
+        <p14:section name="年間スケジュール" id="{d385f3cc-f3ad-45e3-b18d-020112de308f}">
           <p14:sldIdLst>
             <p14:sldId id="257"/>
           </p14:sldIdLst>
         </p14:section>
-        <p14:section name="業務内容" id="{a89b9345-ce45-1de7-819d-65b3d5b07540}">
+        <p14:section name="業務内容" id="{29376c33-4b5c-0a30-31fd-c01006b6a221}">
           <p14:sldIdLst>
             <p14:sldId id="258"/>
           </p14:sldIdLst>
         </p14:section>
-        <p14:section name="イベント紹介" id="{c2907576-f722-6f9f-ff69-abd4ee44b368}">
+        <p14:section name="イベント紹介" id="{848e75c5-bc45-851d-52da-defd06d94552}">
           <p14:sldIdLst>
             <p14:sldId id="259"/>
           </p14:sldIdLst>
         </p14:section>
-        <p14:section name="やって良かったこと" id="{1b61d112-b16a-f1e5-bd9e-7cb73a5c7a10}">
+        <p14:section name="やって良かったこと" id="{c6a1f78c-8dfa-72d2-1027-0ec1819eafda}">
           <p14:sldIdLst>
             <p14:sldId id="260"/>
           </p14:sldIdLst>
         </p14:section>
-        <p14:section name="メッセージ" id="{bd891092-bbd9-613e-470c-0130a616d722}">
+        <p14:section name="メッセージ" id="{6cd25e90-6333-c9d2-6d43-1d7d382d0644}">
           <p14:sldIdLst>
             <p14:sldId id="261"/>
           </p14:sldIdLst>
@@ -1092,8 +1092,8 @@
         </p:nvSpPr>
         <p:spPr>
           <a:xfrm>
-            <a:off x="457200" y="274320"/>
-            <a:ext cx="8229600" cy="640080"/>
+            <a:off x="457200" y="228600"/>
+            <a:ext cx="8229600" cy="685800"/>
           </a:xfrm>
           <a:prstGeom prst="rect">
             <a:avLst/>
@@ -1106,7 +1106,7 @@
           <a:lstStyle>
             <a:lvl1pPr algn="l" indent="0" marL="0">
               <a:buNone/>
-              <a:defRPr lang="en-US" sz="2800" b="1" dirty="0">
+              <a:defRPr lang="en-US" sz="3400" b="1" dirty="0">
                 <a:solidFill>
                   <a:schemeClr val="tx2"/>
                 </a:solidFill>
@@ -1117,7 +1117,7 @@
             <a:pPr algn="l" indent="0" marL="0">
               <a:buNone/>
             </a:pPr>
-            <a:endParaRPr lang="en-US" sz="2800" dirty="0"/>
+            <a:endParaRPr lang="en-US" sz="3400" dirty="0"/>
           </a:p>
         </p:txBody>
       </p:sp>
@@ -1133,7 +1133,7 @@
         </p:nvSpPr>
         <p:spPr>
           <a:xfrm>
-            <a:off x="8321040" y="4754880"/>
+            <a:off x="8321040" y="4800600"/>
             <a:ext cx="457200" cy="274320"/>
           </a:xfrm>
           <a:prstGeom prst="rect">
@@ -1149,7 +1149,7 @@
           <a:bodyPr/>
           <a:lstStyle>
             <a:lvl1pPr>
-              <a:defRPr sz="1000">
+              <a:defRPr sz="1100">
                 <a:solidFill>
                   <a:schemeClr val="accent4"/>
                 </a:solidFill>
@@ -1208,8 +1208,8 @@
         </p:nvSpPr>
         <p:spPr>
           <a:xfrm>
-            <a:off x="548640" y="914400"/>
-            <a:ext cx="8046720" cy="1097280"/>
+            <a:off x="457200" y="914400"/>
+            <a:ext cx="8229600" cy="1097280"/>
           </a:xfrm>
           <a:prstGeom prst="rect">
             <a:avLst/>
@@ -1222,7 +1222,7 @@
           <a:lstStyle>
             <a:lvl1pPr algn="l" indent="0" marL="0">
               <a:buNone/>
-              <a:defRPr lang="en-US" sz="3200" b="1" dirty="0">
+              <a:defRPr lang="en-US" sz="3400" b="1" dirty="0">
                 <a:solidFill>
                   <a:schemeClr val="bg1"/>
                 </a:solidFill>
@@ -1233,7 +1233,7 @@
             <a:pPr algn="l" indent="0" marL="0">
               <a:buNone/>
             </a:pPr>
-            <a:endParaRPr lang="en-US" sz="3200" dirty="0"/>
+            <a:endParaRPr lang="en-US" sz="3400" dirty="0"/>
           </a:p>
         </p:txBody>
       </p:sp>
@@ -1274,7 +1274,7 @@
         </p:nvSpPr>
         <p:spPr>
           <a:xfrm>
-            <a:off x="8321040" y="4754880"/>
+            <a:off x="8321040" y="4800600"/>
             <a:ext cx="457200" cy="274320"/>
           </a:xfrm>
           <a:prstGeom prst="rect">
@@ -1290,7 +1290,7 @@
           <a:bodyPr/>
           <a:lstStyle>
             <a:lvl1pPr>
-              <a:defRPr sz="1000">
+              <a:defRPr sz="1100">
                 <a:solidFill>
                   <a:schemeClr val="accent4"/>
                 </a:solidFill>
@@ -1617,8 +1617,8 @@
         </p:nvSpPr>
         <p:spPr>
           <a:xfrm>
-            <a:off x="548640" y="822960"/>
-            <a:ext cx="4206240" cy="365760"/>
+            <a:off x="548640" y="502920"/>
+            <a:ext cx="4297680" cy="365760"/>
           </a:xfrm>
           <a:prstGeom prst="rect">
             <a:avLst/>
@@ -1634,14 +1634,14 @@
               <a:buNone/>
             </a:pPr>
             <a:r>
-              <a:rPr lang="en-US" sz="1400" b="1" dirty="0">
+              <a:rPr lang="en-US" sz="1700" b="1" dirty="0">
                 <a:solidFill>
                   <a:schemeClr val="accent2"/>
                 </a:solidFill>
               </a:rPr>
               <a:t>現役RAからのプレゼンテーション</a:t>
             </a:r>
-            <a:endParaRPr lang="en-US" sz="1400" dirty="0"/>
+            <a:endParaRPr lang="en-US" sz="1700" dirty="0"/>
           </a:p>
         </p:txBody>
       </p:sp>
@@ -1655,8 +1655,8 @@
         </p:nvSpPr>
         <p:spPr>
           <a:xfrm>
-            <a:off x="548640" y="914400"/>
-            <a:ext cx="8046720" cy="1097280"/>
+            <a:off x="457200" y="914400"/>
+            <a:ext cx="8229600" cy="1097280"/>
           </a:xfrm>
           <a:prstGeom prst="rect">
             <a:avLst/>
@@ -1672,14 +1672,14 @@
               <a:buNone/>
             </a:pPr>
             <a:r>
-              <a:rPr lang="en-US" sz="3200" b="1" dirty="0">
+              <a:rPr lang="en-US" sz="3400" b="1" dirty="0">
                 <a:solidFill>
                   <a:schemeClr val="bg1"/>
                 </a:solidFill>
               </a:rPr>
               <a:t>RA募集説明会</a:t>
             </a:r>
-            <a:endParaRPr lang="en-US" sz="3200" dirty="0"/>
+            <a:endParaRPr lang="en-US" sz="3400" dirty="0"/>
           </a:p>
         </p:txBody>
       </p:sp>
@@ -1691,8 +1691,8 @@
         </p:nvSpPr>
         <p:spPr>
           <a:xfrm>
-            <a:off x="548640" y="2011680"/>
-            <a:ext cx="4206240" cy="457200"/>
+            <a:off x="548640" y="1828800"/>
+            <a:ext cx="4297680" cy="502920"/>
           </a:xfrm>
           <a:prstGeom prst="rect">
             <a:avLst/>
@@ -1708,14 +1708,14 @@
               <a:buNone/>
             </a:pPr>
             <a:r>
-              <a:rPr lang="en-US" sz="2000" dirty="0">
+              <a:rPr lang="en-US" sz="2600" dirty="0">
                 <a:solidFill>
                   <a:schemeClr val="bg1"/>
                 </a:solidFill>
               </a:rPr>
               <a:t>東大宮学生寮</a:t>
             </a:r>
-            <a:endParaRPr lang="en-US" sz="2000" dirty="0"/>
+            <a:endParaRPr lang="en-US" sz="2600" dirty="0"/>
           </a:p>
         </p:txBody>
       </p:sp>
@@ -1727,8 +1727,8 @@
         </p:nvSpPr>
         <p:spPr>
           <a:xfrm>
-            <a:off x="548640" y="2743200"/>
-            <a:ext cx="4297680" cy="1463040"/>
+            <a:off x="548640" y="2560320"/>
+            <a:ext cx="4297680" cy="1783080"/>
           </a:xfrm>
           <a:prstGeom prst="rect">
             <a:avLst/>
@@ -1748,14 +1748,14 @@
               <a:buChar char="•"/>
             </a:pPr>
             <a:r>
-              <a:rPr lang="en-US" sz="1300" dirty="0">
+              <a:rPr lang="en-US" sz="1700" dirty="0">
                 <a:solidFill>
                   <a:schemeClr val="bg2"/>
                 </a:solidFill>
               </a:rPr>
               <a:t>年間スケジュール</a:t>
             </a:r>
-            <a:endParaRPr lang="en-US" sz="1300" dirty="0"/>
+            <a:endParaRPr lang="en-US" sz="1700" dirty="0"/>
           </a:p>
           <a:p>
             <a:pPr marL="342900" indent="-342900">
@@ -1766,14 +1766,14 @@
               <a:buChar char="•"/>
             </a:pPr>
             <a:r>
-              <a:rPr lang="en-US" sz="1300" dirty="0">
+              <a:rPr lang="en-US" sz="1700" dirty="0">
                 <a:solidFill>
                   <a:schemeClr val="bg2"/>
                 </a:solidFill>
               </a:rPr>
               <a:t>具体的な業務内容</a:t>
             </a:r>
-            <a:endParaRPr lang="en-US" sz="1300" dirty="0"/>
+            <a:endParaRPr lang="en-US" sz="1700" dirty="0"/>
           </a:p>
           <a:p>
             <a:pPr marL="342900" indent="-342900">
@@ -1784,14 +1784,14 @@
               <a:buChar char="•"/>
             </a:pPr>
             <a:r>
-              <a:rPr lang="en-US" sz="1300" dirty="0">
+              <a:rPr lang="en-US" sz="1700" dirty="0">
                 <a:solidFill>
                   <a:schemeClr val="bg2"/>
                 </a:solidFill>
               </a:rPr>
               <a:t>イベント紹介</a:t>
             </a:r>
-            <a:endParaRPr lang="en-US" sz="1300" dirty="0"/>
+            <a:endParaRPr lang="en-US" sz="1700" dirty="0"/>
           </a:p>
           <a:p>
             <a:pPr marL="342900" indent="-342900">
@@ -1802,14 +1802,14 @@
               <a:buChar char="•"/>
             </a:pPr>
             <a:r>
-              <a:rPr lang="en-US" sz="1300" dirty="0">
+              <a:rPr lang="en-US" sz="1700" dirty="0">
                 <a:solidFill>
                   <a:schemeClr val="bg2"/>
                 </a:solidFill>
               </a:rPr>
-              <a:t>RAをやって良かったこと・大変だったこと</a:t>
-            </a:r>
-            <a:endParaRPr lang="en-US" sz="1300" dirty="0"/>
+              <a:t>良かったこと・大変だったこと</a:t>
+            </a:r>
+            <a:endParaRPr lang="en-US" sz="1700" dirty="0"/>
           </a:p>
           <a:p>
             <a:pPr marL="342900" indent="-342900">
@@ -1820,14 +1820,14 @@
               <a:buChar char="•"/>
             </a:pPr>
             <a:r>
-              <a:rPr lang="en-US" sz="1300" dirty="0">
+              <a:rPr lang="en-US" sz="1700" dirty="0">
                 <a:solidFill>
                   <a:schemeClr val="bg2"/>
                 </a:solidFill>
               </a:rPr>
               <a:t>応募を考えている皆さんへ</a:t>
             </a:r>
-            <a:endParaRPr lang="en-US" sz="1300" dirty="0"/>
+            <a:endParaRPr lang="en-US" sz="1700" dirty="0"/>
           </a:p>
         </p:txBody>
       </p:sp>
@@ -1839,8 +1839,8 @@
         </p:nvSpPr>
         <p:spPr>
           <a:xfrm>
-            <a:off x="548640" y="4434840"/>
-            <a:ext cx="4297680" cy="320040"/>
+            <a:off x="548640" y="4480560"/>
+            <a:ext cx="4297680" cy="365760"/>
           </a:xfrm>
           <a:prstGeom prst="rect">
             <a:avLst/>
@@ -1856,14 +1856,14 @@
               <a:buNone/>
             </a:pPr>
             <a:r>
-              <a:rPr lang="en-US" sz="1000" dirty="0">
+              <a:rPr lang="en-US" sz="1200" dirty="0">
                 <a:solidFill>
                   <a:schemeClr val="accent6"/>
                 </a:solidFill>
               </a:rPr>
-              <a:t>2026年10月23日（金）　大宮キャンパス 2号館 2103教室</a:t>
-            </a:r>
-            <a:endParaRPr lang="en-US" sz="1000" dirty="0"/>
+              <a:t>2026年10月23日（金）　2号館 2103教室</a:t>
+            </a:r>
+            <a:endParaRPr lang="en-US" sz="1200" dirty="0"/>
           </a:p>
         </p:txBody>
       </p:sp>
@@ -1902,8 +1902,8 @@
         </p:nvSpPr>
         <p:spPr>
           <a:xfrm>
-            <a:off x="457200" y="274320"/>
-            <a:ext cx="8229600" cy="640080"/>
+            <a:off x="457200" y="228600"/>
+            <a:ext cx="8229600" cy="685800"/>
           </a:xfrm>
           <a:prstGeom prst="rect">
             <a:avLst/>
@@ -1919,14 +1919,14 @@
               <a:buNone/>
             </a:pPr>
             <a:r>
-              <a:rPr lang="en-US" sz="2800" b="1" dirty="0">
+              <a:rPr lang="en-US" sz="3400" b="1" dirty="0">
                 <a:solidFill>
                   <a:schemeClr val="tx2"/>
                 </a:solidFill>
               </a:rPr>
               <a:t>年間スケジュール</a:t>
             </a:r>
-            <a:endParaRPr lang="en-US" sz="2800" dirty="0"/>
+            <a:endParaRPr lang="en-US" sz="3400" dirty="0"/>
           </a:p>
         </p:txBody>
       </p:sp>
@@ -1938,7 +1938,7 @@
         </p:nvSpPr>
         <p:spPr>
           <a:xfrm>
-            <a:off x="594360" y="1143000"/>
+            <a:off x="594360" y="1097280"/>
             <a:ext cx="640080" cy="640080"/>
           </a:xfrm>
           <a:prstGeom prst="ellipse">
@@ -1971,7 +1971,7 @@
         </p:blipFill>
         <p:spPr>
           <a:xfrm>
-            <a:off x="749808" y="1298448"/>
+            <a:off x="749808" y="1252728"/>
             <a:ext cx="329184" cy="329184"/>
           </a:xfrm>
           <a:prstGeom prst="rect">
@@ -1987,8 +1987,8 @@
         </p:nvSpPr>
         <p:spPr>
           <a:xfrm>
-            <a:off x="1325880" y="1234440"/>
-            <a:ext cx="1051560" cy="457200"/>
+            <a:off x="1325880" y="1051560"/>
+            <a:ext cx="1051560" cy="731520"/>
           </a:xfrm>
           <a:prstGeom prst="rect">
             <a:avLst/>
@@ -2004,25 +2004,28 @@
               <a:buNone/>
             </a:pPr>
             <a:r>
-              <a:rPr lang="en-US" sz="2000" b="1" dirty="0">
+              <a:rPr lang="en-US" sz="2400" b="1" dirty="0">
                 <a:solidFill>
                   <a:schemeClr val="accent3"/>
                 </a:solidFill>
               </a:rPr>
               <a:t>春</a:t>
             </a:r>
+            <a:endParaRPr lang="en-US" sz="2400" dirty="0"/>
+          </a:p>
+          <a:p>
             <a:pPr indent="0" marL="0">
               <a:buNone/>
             </a:pPr>
             <a:r>
-              <a:rPr lang="en-US" sz="1200" dirty="0">
+              <a:rPr lang="en-US" sz="1500" dirty="0">
                 <a:solidFill>
                   <a:schemeClr val="tx1"/>
                 </a:solidFill>
               </a:rPr>
-              <a:t>  2〜4月</a:t>
-            </a:r>
-            <a:endParaRPr lang="en-US" sz="2000" dirty="0"/>
+              <a:t>2〜4月</a:t>
+            </a:r>
+            <a:endParaRPr lang="en-US" sz="2400" dirty="0"/>
           </a:p>
         </p:txBody>
       </p:sp>
@@ -2034,8 +2037,8 @@
         </p:nvSpPr>
         <p:spPr>
           <a:xfrm>
-            <a:off x="457200" y="1965960"/>
-            <a:ext cx="1920240" cy="1965960"/>
+            <a:off x="457200" y="1874520"/>
+            <a:ext cx="1920240" cy="2103120"/>
           </a:xfrm>
           <a:prstGeom prst="roundRect">
             <a:avLst>
@@ -2061,8 +2064,8 @@
         </p:nvSpPr>
         <p:spPr>
           <a:xfrm>
-            <a:off x="566928" y="2075688"/>
-            <a:ext cx="1700784" cy="1792224"/>
+            <a:off x="530352" y="1993392"/>
+            <a:ext cx="1773936" cy="1920240"/>
           </a:xfrm>
           <a:prstGeom prst="rect">
             <a:avLst/>
@@ -2076,74 +2079,74 @@
           <a:p>
             <a:pPr marL="152400" indent="-152400">
               <a:spcAft>
-                <a:spcPts val="600"/>
+                <a:spcPts val="800"/>
               </a:spcAft>
               <a:buSzPct val="100000"/>
               <a:buChar char="•"/>
             </a:pPr>
             <a:r>
-              <a:rPr lang="en-US" sz="1200" dirty="0">
+              <a:rPr lang="en-US" sz="1600" dirty="0">
                 <a:solidFill>
                   <a:schemeClr val="tx1"/>
                 </a:solidFill>
               </a:rPr>
               <a:t>入寮サポート</a:t>
             </a:r>
-            <a:endParaRPr lang="en-US" sz="1200" dirty="0"/>
+            <a:endParaRPr lang="en-US" sz="1600" dirty="0"/>
           </a:p>
           <a:p>
             <a:pPr marL="152400" indent="-152400">
               <a:spcAft>
-                <a:spcPts val="600"/>
+                <a:spcPts val="800"/>
               </a:spcAft>
               <a:buSzPct val="100000"/>
               <a:buChar char="•"/>
             </a:pPr>
             <a:r>
-              <a:rPr lang="en-US" sz="1200" dirty="0">
+              <a:rPr lang="en-US" sz="1600" dirty="0">
                 <a:solidFill>
                   <a:schemeClr val="tx1"/>
                 </a:solidFill>
               </a:rPr>
-              <a:t>オリエンテーション</a:t>
-            </a:r>
-            <a:endParaRPr lang="en-US" sz="1200" dirty="0"/>
+              <a:t>寮内ガイダンス</a:t>
+            </a:r>
+            <a:endParaRPr lang="en-US" sz="1600" dirty="0"/>
           </a:p>
           <a:p>
             <a:pPr marL="152400" indent="-152400">
               <a:spcAft>
-                <a:spcPts val="600"/>
+                <a:spcPts val="800"/>
               </a:spcAft>
               <a:buSzPct val="100000"/>
               <a:buChar char="•"/>
             </a:pPr>
             <a:r>
-              <a:rPr lang="en-US" sz="1200" dirty="0">
+              <a:rPr lang="en-US" sz="1600" dirty="0">
                 <a:solidFill>
                   <a:schemeClr val="tx1"/>
                 </a:solidFill>
               </a:rPr>
               <a:t>履修登録相談会</a:t>
             </a:r>
-            <a:endParaRPr lang="en-US" sz="1200" dirty="0"/>
+            <a:endParaRPr lang="en-US" sz="1600" dirty="0"/>
           </a:p>
           <a:p>
             <a:pPr marL="152400" indent="-152400">
               <a:spcAft>
-                <a:spcPts val="600"/>
+                <a:spcPts val="800"/>
               </a:spcAft>
               <a:buSzPct val="100000"/>
               <a:buChar char="•"/>
             </a:pPr>
             <a:r>
-              <a:rPr lang="en-US" sz="1200" dirty="0">
+              <a:rPr lang="en-US" sz="1600" dirty="0">
                 <a:solidFill>
                   <a:schemeClr val="tx1"/>
                 </a:solidFill>
               </a:rPr>
               <a:t>新入生歓迎会</a:t>
             </a:r>
-            <a:endParaRPr lang="en-US" sz="1200" dirty="0"/>
+            <a:endParaRPr lang="en-US" sz="1600" dirty="0"/>
           </a:p>
         </p:txBody>
       </p:sp>
@@ -2155,7 +2158,7 @@
         </p:nvSpPr>
         <p:spPr>
           <a:xfrm>
-            <a:off x="2697480" y="1143000"/>
+            <a:off x="2697480" y="1097280"/>
             <a:ext cx="640080" cy="640080"/>
           </a:xfrm>
           <a:prstGeom prst="ellipse">
@@ -2188,7 +2191,7 @@
         </p:blipFill>
         <p:spPr>
           <a:xfrm>
-            <a:off x="2852928" y="1298448"/>
+            <a:off x="2852928" y="1252728"/>
             <a:ext cx="329184" cy="329184"/>
           </a:xfrm>
           <a:prstGeom prst="rect">
@@ -2204,8 +2207,8 @@
         </p:nvSpPr>
         <p:spPr>
           <a:xfrm>
-            <a:off x="3429000" y="1234440"/>
-            <a:ext cx="1051560" cy="457200"/>
+            <a:off x="3429000" y="1051560"/>
+            <a:ext cx="1051560" cy="731520"/>
           </a:xfrm>
           <a:prstGeom prst="rect">
             <a:avLst/>
@@ -2221,25 +2224,28 @@
               <a:buNone/>
             </a:pPr>
             <a:r>
-              <a:rPr lang="en-US" sz="2000" b="1" dirty="0">
+              <a:rPr lang="en-US" sz="2400" b="1" dirty="0">
                 <a:solidFill>
                   <a:schemeClr val="accent2"/>
                 </a:solidFill>
               </a:rPr>
               <a:t>夏</a:t>
             </a:r>
+            <a:endParaRPr lang="en-US" sz="2400" dirty="0"/>
+          </a:p>
+          <a:p>
             <a:pPr indent="0" marL="0">
               <a:buNone/>
             </a:pPr>
             <a:r>
-              <a:rPr lang="en-US" sz="1200" dirty="0">
+              <a:rPr lang="en-US" sz="1500" dirty="0">
                 <a:solidFill>
                   <a:schemeClr val="tx1"/>
                 </a:solidFill>
               </a:rPr>
-              <a:t>  5〜8月</a:t>
-            </a:r>
-            <a:endParaRPr lang="en-US" sz="2000" dirty="0"/>
+              <a:t>5〜8月</a:t>
+            </a:r>
+            <a:endParaRPr lang="en-US" sz="2400" dirty="0"/>
           </a:p>
         </p:txBody>
       </p:sp>
@@ -2251,8 +2257,8 @@
         </p:nvSpPr>
         <p:spPr>
           <a:xfrm>
-            <a:off x="2560320" y="1965960"/>
-            <a:ext cx="1920240" cy="1965960"/>
+            <a:off x="2560320" y="1874520"/>
+            <a:ext cx="1920240" cy="2103120"/>
           </a:xfrm>
           <a:prstGeom prst="roundRect">
             <a:avLst>
@@ -2278,8 +2284,8 @@
         </p:nvSpPr>
         <p:spPr>
           <a:xfrm>
-            <a:off x="2670048" y="2075688"/>
-            <a:ext cx="1700784" cy="1792224"/>
+            <a:off x="2633472" y="1993392"/>
+            <a:ext cx="1773936" cy="1920240"/>
           </a:xfrm>
           <a:prstGeom prst="rect">
             <a:avLst/>
@@ -2293,38 +2299,38 @@
           <a:p>
             <a:pPr marL="152400" indent="-152400">
               <a:spcAft>
-                <a:spcPts val="600"/>
+                <a:spcPts val="800"/>
               </a:spcAft>
               <a:buSzPct val="100000"/>
               <a:buChar char="•"/>
             </a:pPr>
             <a:r>
-              <a:rPr lang="en-US" sz="1200" dirty="0">
+              <a:rPr lang="en-US" sz="1600" dirty="0">
                 <a:solidFill>
                   <a:schemeClr val="tx1"/>
                 </a:solidFill>
               </a:rPr>
               <a:t>クリーン大作戦</a:t>
             </a:r>
-            <a:endParaRPr lang="en-US" sz="1200" dirty="0"/>
+            <a:endParaRPr lang="en-US" sz="1600" dirty="0"/>
           </a:p>
           <a:p>
             <a:pPr marL="152400" indent="-152400">
               <a:spcAft>
-                <a:spcPts val="600"/>
+                <a:spcPts val="800"/>
               </a:spcAft>
               <a:buSzPct val="100000"/>
               <a:buChar char="•"/>
             </a:pPr>
             <a:r>
-              <a:rPr lang="en-US" sz="1200" dirty="0">
+              <a:rPr lang="en-US" sz="1600" dirty="0">
                 <a:solidFill>
                   <a:schemeClr val="tx1"/>
                 </a:solidFill>
               </a:rPr>
-              <a:t>夏休み期間の対応</a:t>
-            </a:r>
-            <a:endParaRPr lang="en-US" sz="1200" dirty="0"/>
+              <a:t>夏休み中の対応</a:t>
+            </a:r>
+            <a:endParaRPr lang="en-US" sz="1600" dirty="0"/>
           </a:p>
         </p:txBody>
       </p:sp>
@@ -2336,7 +2342,7 @@
         </p:nvSpPr>
         <p:spPr>
           <a:xfrm>
-            <a:off x="4800600" y="1143000"/>
+            <a:off x="4800600" y="1097280"/>
             <a:ext cx="640080" cy="640080"/>
           </a:xfrm>
           <a:prstGeom prst="ellipse">
@@ -2369,7 +2375,7 @@
         </p:blipFill>
         <p:spPr>
           <a:xfrm>
-            <a:off x="4956048" y="1298448"/>
+            <a:off x="4956048" y="1252728"/>
             <a:ext cx="329184" cy="329184"/>
           </a:xfrm>
           <a:prstGeom prst="rect">
@@ -2385,8 +2391,8 @@
         </p:nvSpPr>
         <p:spPr>
           <a:xfrm>
-            <a:off x="5532120" y="1234440"/>
-            <a:ext cx="1051560" cy="457200"/>
+            <a:off x="5532120" y="1051560"/>
+            <a:ext cx="1051560" cy="731520"/>
           </a:xfrm>
           <a:prstGeom prst="rect">
             <a:avLst/>
@@ -2402,25 +2408,28 @@
               <a:buNone/>
             </a:pPr>
             <a:r>
-              <a:rPr lang="en-US" sz="2000" b="1" dirty="0">
+              <a:rPr lang="en-US" sz="2400" b="1" dirty="0">
                 <a:solidFill>
                   <a:schemeClr val="accent5"/>
                 </a:solidFill>
               </a:rPr>
               <a:t>秋</a:t>
             </a:r>
+            <a:endParaRPr lang="en-US" sz="2400" dirty="0"/>
+          </a:p>
+          <a:p>
             <a:pPr indent="0" marL="0">
               <a:buNone/>
             </a:pPr>
             <a:r>
-              <a:rPr lang="en-US" sz="1200" dirty="0">
+              <a:rPr lang="en-US" sz="1500" dirty="0">
                 <a:solidFill>
                   <a:schemeClr val="tx1"/>
                 </a:solidFill>
               </a:rPr>
-              <a:t>  9〜12月</a:t>
-            </a:r>
-            <a:endParaRPr lang="en-US" sz="2000" dirty="0"/>
+              <a:t>9〜12月</a:t>
+            </a:r>
+            <a:endParaRPr lang="en-US" sz="2400" dirty="0"/>
           </a:p>
         </p:txBody>
       </p:sp>
@@ -2432,8 +2441,8 @@
         </p:nvSpPr>
         <p:spPr>
           <a:xfrm>
-            <a:off x="4663440" y="1965960"/>
-            <a:ext cx="1920240" cy="1965960"/>
+            <a:off x="4663440" y="1874520"/>
+            <a:ext cx="1920240" cy="2103120"/>
           </a:xfrm>
           <a:prstGeom prst="roundRect">
             <a:avLst>
@@ -2459,8 +2468,8 @@
         </p:nvSpPr>
         <p:spPr>
           <a:xfrm>
-            <a:off x="4773168" y="2075688"/>
-            <a:ext cx="1700784" cy="1792224"/>
+            <a:off x="4736592" y="1993392"/>
+            <a:ext cx="1773936" cy="1920240"/>
           </a:xfrm>
           <a:prstGeom prst="rect">
             <a:avLst/>
@@ -2474,74 +2483,74 @@
           <a:p>
             <a:pPr marL="152400" indent="-152400">
               <a:spcAft>
-                <a:spcPts val="600"/>
+                <a:spcPts val="800"/>
               </a:spcAft>
               <a:buSzPct val="100000"/>
               <a:buChar char="•"/>
             </a:pPr>
             <a:r>
-              <a:rPr lang="en-US" sz="1200" dirty="0">
+              <a:rPr lang="en-US" sz="1600" dirty="0">
                 <a:solidFill>
                   <a:schemeClr val="tx1"/>
                 </a:solidFill>
               </a:rPr>
               <a:t>防災訓練</a:t>
             </a:r>
-            <a:endParaRPr lang="en-US" sz="1200" dirty="0"/>
+            <a:endParaRPr lang="en-US" sz="1600" dirty="0"/>
           </a:p>
           <a:p>
             <a:pPr marL="152400" indent="-152400">
               <a:spcAft>
-                <a:spcPts val="600"/>
+                <a:spcPts val="800"/>
               </a:spcAft>
               <a:buSzPct val="100000"/>
               <a:buChar char="•"/>
             </a:pPr>
             <a:r>
-              <a:rPr lang="en-US" sz="1200" dirty="0">
+              <a:rPr lang="en-US" sz="1600" dirty="0">
                 <a:solidFill>
                   <a:schemeClr val="tx1"/>
                 </a:solidFill>
               </a:rPr>
               <a:t>クリーン大作戦</a:t>
             </a:r>
-            <a:endParaRPr lang="en-US" sz="1200" dirty="0"/>
+            <a:endParaRPr lang="en-US" sz="1600" dirty="0"/>
           </a:p>
           <a:p>
             <a:pPr marL="152400" indent="-152400">
               <a:spcAft>
-                <a:spcPts val="600"/>
+                <a:spcPts val="800"/>
               </a:spcAft>
               <a:buSzPct val="100000"/>
               <a:buChar char="•"/>
             </a:pPr>
             <a:r>
-              <a:rPr lang="en-US" sz="1200" dirty="0">
+              <a:rPr lang="en-US" sz="1600" dirty="0">
                 <a:solidFill>
                   <a:schemeClr val="tx1"/>
                 </a:solidFill>
               </a:rPr>
-              <a:t>冬休み期間の対応</a:t>
-            </a:r>
-            <a:endParaRPr lang="en-US" sz="1200" dirty="0"/>
+              <a:t>冬休み中の対応</a:t>
+            </a:r>
+            <a:endParaRPr lang="en-US" sz="1600" dirty="0"/>
           </a:p>
           <a:p>
             <a:pPr marL="152400" indent="-152400">
               <a:spcAft>
-                <a:spcPts val="600"/>
+                <a:spcPts val="800"/>
               </a:spcAft>
               <a:buSzPct val="100000"/>
               <a:buChar char="•"/>
             </a:pPr>
             <a:r>
-              <a:rPr lang="en-US" sz="1200" dirty="0">
+              <a:rPr lang="en-US" sz="1600" dirty="0">
                 <a:solidFill>
                   <a:schemeClr val="tx1"/>
                 </a:solidFill>
               </a:rPr>
               <a:t>RA募集説明会</a:t>
             </a:r>
-            <a:endParaRPr lang="en-US" sz="1200" dirty="0"/>
+            <a:endParaRPr lang="en-US" sz="1600" dirty="0"/>
           </a:p>
         </p:txBody>
       </p:sp>
@@ -2553,7 +2562,7 @@
         </p:nvSpPr>
         <p:spPr>
           <a:xfrm>
-            <a:off x="6903720" y="1143000"/>
+            <a:off x="6903720" y="1097280"/>
             <a:ext cx="640080" cy="640080"/>
           </a:xfrm>
           <a:prstGeom prst="ellipse">
@@ -2586,7 +2595,7 @@
         </p:blipFill>
         <p:spPr>
           <a:xfrm>
-            <a:off x="7059168" y="1298448"/>
+            <a:off x="7059168" y="1252728"/>
             <a:ext cx="329184" cy="329184"/>
           </a:xfrm>
           <a:prstGeom prst="rect">
@@ -2602,8 +2611,8 @@
         </p:nvSpPr>
         <p:spPr>
           <a:xfrm>
-            <a:off x="7635240" y="1234440"/>
-            <a:ext cx="1051560" cy="457200"/>
+            <a:off x="7635240" y="1051560"/>
+            <a:ext cx="1051560" cy="731520"/>
           </a:xfrm>
           <a:prstGeom prst="rect">
             <a:avLst/>
@@ -2619,25 +2628,28 @@
               <a:buNone/>
             </a:pPr>
             <a:r>
-              <a:rPr lang="en-US" sz="2000" b="1" dirty="0">
+              <a:rPr lang="en-US" sz="2400" b="1" dirty="0">
                 <a:solidFill>
                   <a:schemeClr val="accent4"/>
                 </a:solidFill>
               </a:rPr>
               <a:t>冬</a:t>
             </a:r>
+            <a:endParaRPr lang="en-US" sz="2400" dirty="0"/>
+          </a:p>
+          <a:p>
             <a:pPr indent="0" marL="0">
               <a:buNone/>
             </a:pPr>
             <a:r>
-              <a:rPr lang="en-US" sz="1200" dirty="0">
+              <a:rPr lang="en-US" sz="1500" dirty="0">
                 <a:solidFill>
                   <a:schemeClr val="tx1"/>
                 </a:solidFill>
               </a:rPr>
-              <a:t>  1月〜</a:t>
-            </a:r>
-            <a:endParaRPr lang="en-US" sz="2000" dirty="0"/>
+              <a:t>1月〜</a:t>
+            </a:r>
+            <a:endParaRPr lang="en-US" sz="2400" dirty="0"/>
           </a:p>
         </p:txBody>
       </p:sp>
@@ -2649,8 +2661,8 @@
         </p:nvSpPr>
         <p:spPr>
           <a:xfrm>
-            <a:off x="6766560" y="1965960"/>
-            <a:ext cx="1920240" cy="1965960"/>
+            <a:off x="6766560" y="1874520"/>
+            <a:ext cx="1920240" cy="2103120"/>
           </a:xfrm>
           <a:prstGeom prst="roundRect">
             <a:avLst>
@@ -2676,8 +2688,8 @@
         </p:nvSpPr>
         <p:spPr>
           <a:xfrm>
-            <a:off x="6876288" y="2075688"/>
-            <a:ext cx="1700784" cy="1792224"/>
+            <a:off x="6839712" y="1993392"/>
+            <a:ext cx="1773936" cy="1920240"/>
           </a:xfrm>
           <a:prstGeom prst="rect">
             <a:avLst/>
@@ -2691,38 +2703,38 @@
           <a:p>
             <a:pPr marL="152400" indent="-152400">
               <a:spcAft>
-                <a:spcPts val="600"/>
+                <a:spcPts val="800"/>
               </a:spcAft>
               <a:buSzPct val="100000"/>
               <a:buChar char="•"/>
             </a:pPr>
             <a:r>
-              <a:rPr lang="en-US" sz="1200" dirty="0">
+              <a:rPr lang="en-US" sz="1600" dirty="0">
                 <a:solidFill>
                   <a:schemeClr val="tx1"/>
                 </a:solidFill>
               </a:rPr>
-              <a:t>新寮生の選考補助</a:t>
-            </a:r>
-            <a:endParaRPr lang="en-US" sz="1200" dirty="0"/>
+              <a:t>選考サポート</a:t>
+            </a:r>
+            <a:endParaRPr lang="en-US" sz="1600" dirty="0"/>
           </a:p>
           <a:p>
             <a:pPr marL="152400" indent="-152400">
               <a:spcAft>
-                <a:spcPts val="600"/>
+                <a:spcPts val="800"/>
               </a:spcAft>
               <a:buSzPct val="100000"/>
               <a:buChar char="•"/>
             </a:pPr>
             <a:r>
-              <a:rPr lang="en-US" sz="1200" dirty="0">
+              <a:rPr lang="en-US" sz="1600" dirty="0">
                 <a:solidFill>
                   <a:schemeClr val="tx1"/>
                 </a:solidFill>
               </a:rPr>
-              <a:t>次年度への引継ぎ</a:t>
-            </a:r>
-            <a:endParaRPr lang="en-US" sz="1200" dirty="0"/>
+              <a:t>RA引継ぎ</a:t>
+            </a:r>
+            <a:endParaRPr lang="en-US" sz="1600" dirty="0"/>
           </a:p>
         </p:txBody>
       </p:sp>
@@ -2734,12 +2746,12 @@
         </p:nvSpPr>
         <p:spPr>
           <a:xfrm>
-            <a:off x="457200" y="4160520"/>
-            <a:ext cx="8229600" cy="502920"/>
+            <a:off x="457200" y="4114800"/>
+            <a:ext cx="8229600" cy="594360"/>
           </a:xfrm>
           <a:prstGeom prst="roundRect">
             <a:avLst>
-              <a:gd name="adj" fmla="val 14545"/>
+              <a:gd name="adj" fmla="val 12308"/>
             </a:avLst>
           </a:prstGeom>
           <a:solidFill>
@@ -2769,8 +2781,8 @@
         </p:blipFill>
         <p:spPr>
           <a:xfrm>
-            <a:off x="640080" y="4270248"/>
-            <a:ext cx="274320" cy="274320"/>
+            <a:off x="640080" y="4251960"/>
+            <a:ext cx="320040" cy="320040"/>
           </a:xfrm>
           <a:prstGeom prst="rect">
             <a:avLst/>
@@ -2785,8 +2797,8 @@
         </p:nvSpPr>
         <p:spPr>
           <a:xfrm>
-            <a:off x="1051560" y="4160520"/>
-            <a:ext cx="7498080" cy="502920"/>
+            <a:off x="1143000" y="4114800"/>
+            <a:ext cx="7406640" cy="594360"/>
           </a:xfrm>
           <a:prstGeom prst="rect">
             <a:avLst/>
@@ -2802,25 +2814,25 @@
               <a:buNone/>
             </a:pPr>
             <a:r>
-              <a:rPr lang="en-US" sz="1300" b="1" dirty="0">
+              <a:rPr lang="en-US" sz="1800" b="1" dirty="0">
                 <a:solidFill>
                   <a:schemeClr val="accent2"/>
                 </a:solidFill>
               </a:rPr>
-              <a:t>毎月の定例：</a:t>
+              <a:t>毎月：</a:t>
             </a:r>
             <a:pPr indent="0" marL="0">
               <a:buNone/>
             </a:pPr>
             <a:r>
-              <a:rPr lang="en-US" sz="1300" dirty="0">
+              <a:rPr lang="en-US" sz="1800" dirty="0">
                 <a:solidFill>
                   <a:schemeClr val="bg1"/>
                 </a:solidFill>
               </a:rPr>
-              <a:t>RAミーティング（大学・寮母さんと）／各階のフロアミーティング</a:t>
-            </a:r>
-            <a:endParaRPr lang="en-US" sz="1300" dirty="0"/>
+              <a:t>RAミーティング ／ 各階のフロアミーティング</a:t>
+            </a:r>
+            <a:endParaRPr lang="en-US" sz="1800" dirty="0"/>
           </a:p>
         </p:txBody>
       </p:sp>
@@ -2836,7 +2848,7 @@
         </p:nvSpPr>
         <p:spPr>
           <a:xfrm>
-            <a:off x="8321040" y="4754880"/>
+            <a:off x="8321040" y="4800600"/>
             <a:ext cx="457200" cy="274320"/>
           </a:xfrm>
           <a:prstGeom prst="rect">
@@ -2852,7 +2864,7 @@
           <a:bodyPr/>
           <a:lstStyle>
             <a:lvl1pPr>
-              <a:defRPr sz="1000">
+              <a:defRPr sz="1100">
                 <a:solidFill>
                   <a:schemeClr val="accent4"/>
                 </a:solidFill>
@@ -2904,8 +2916,8 @@
         </p:nvSpPr>
         <p:spPr>
           <a:xfrm>
-            <a:off x="457200" y="274320"/>
-            <a:ext cx="8229600" cy="640080"/>
+            <a:off x="457200" y="228600"/>
+            <a:ext cx="8229600" cy="685800"/>
           </a:xfrm>
           <a:prstGeom prst="rect">
             <a:avLst/>
@@ -2921,14 +2933,14 @@
               <a:buNone/>
             </a:pPr>
             <a:r>
-              <a:rPr lang="en-US" sz="2800" b="1" dirty="0">
+              <a:rPr lang="en-US" sz="3400" b="1" dirty="0">
                 <a:solidFill>
                   <a:schemeClr val="tx2"/>
                 </a:solidFill>
               </a:rPr>
               <a:t>具体的な業務内容</a:t>
             </a:r>
-            <a:endParaRPr lang="en-US" sz="2800" dirty="0"/>
+            <a:endParaRPr lang="en-US" sz="3400" dirty="0"/>
           </a:p>
         </p:txBody>
       </p:sp>
@@ -2940,12 +2952,12 @@
         </p:nvSpPr>
         <p:spPr>
           <a:xfrm>
-            <a:off x="457200" y="1143000"/>
-            <a:ext cx="2606040" cy="1600200"/>
+            <a:off x="457200" y="1097280"/>
+            <a:ext cx="2606040" cy="1691640"/>
           </a:xfrm>
           <a:prstGeom prst="roundRect">
             <a:avLst>
-              <a:gd name="adj" fmla="val 4571"/>
+              <a:gd name="adj" fmla="val 4324"/>
             </a:avLst>
           </a:prstGeom>
           <a:solidFill>
@@ -2974,7 +2986,7 @@
         </p:nvSpPr>
         <p:spPr>
           <a:xfrm>
-            <a:off x="640080" y="1325880"/>
+            <a:off x="640080" y="1280160"/>
             <a:ext cx="502920" cy="502920"/>
           </a:xfrm>
           <a:prstGeom prst="ellipse">
@@ -3007,7 +3019,7 @@
         </p:blipFill>
         <p:spPr>
           <a:xfrm>
-            <a:off x="758952" y="1444752"/>
+            <a:off x="758952" y="1399032"/>
             <a:ext cx="265176" cy="265176"/>
           </a:xfrm>
           <a:prstGeom prst="rect">
@@ -3023,8 +3035,8 @@
         </p:nvSpPr>
         <p:spPr>
           <a:xfrm>
-            <a:off x="1261872" y="1325880"/>
-            <a:ext cx="1691640" cy="502920"/>
+            <a:off x="1234440" y="1234440"/>
+            <a:ext cx="1737360" cy="594360"/>
           </a:xfrm>
           <a:prstGeom prst="rect">
             <a:avLst/>
@@ -3040,14 +3052,14 @@
               <a:buNone/>
             </a:pPr>
             <a:r>
-              <a:rPr lang="en-US" sz="1400" b="1" dirty="0">
+              <a:rPr lang="en-US" sz="1700" b="1" dirty="0">
                 <a:solidFill>
                   <a:schemeClr val="tx2"/>
                 </a:solidFill>
               </a:rPr>
-              <a:t>フロアミーティング</a:t>
-            </a:r>
-            <a:endParaRPr lang="en-US" sz="1400" dirty="0"/>
+              <a:t>フロア会議</a:t>
+            </a:r>
+            <a:endParaRPr lang="en-US" sz="1700" dirty="0"/>
           </a:p>
         </p:txBody>
       </p:sp>
@@ -3059,8 +3071,8 @@
         </p:nvSpPr>
         <p:spPr>
           <a:xfrm>
-            <a:off x="640080" y="1947672"/>
-            <a:ext cx="2240280" cy="685800"/>
+            <a:off x="640080" y="1901952"/>
+            <a:ext cx="2286000" cy="777240"/>
           </a:xfrm>
           <a:prstGeom prst="rect">
             <a:avLst/>
@@ -3076,14 +3088,14 @@
               <a:buNone/>
             </a:pPr>
             <a:r>
-              <a:rPr lang="en-US" sz="1200" dirty="0">
+              <a:rPr lang="en-US" sz="1500" dirty="0">
                 <a:solidFill>
                   <a:schemeClr val="tx1"/>
                 </a:solidFill>
               </a:rPr>
-              <a:t>担当フロアの寮生を集め、ルールの確認や連絡事項を共有</a:t>
-            </a:r>
-            <a:endParaRPr lang="en-US" sz="1200" dirty="0"/>
+              <a:t>各階の寮生とルールや連絡を共有</a:t>
+            </a:r>
+            <a:endParaRPr lang="en-US" sz="1500" dirty="0"/>
           </a:p>
         </p:txBody>
       </p:sp>
@@ -3095,12 +3107,12 @@
         </p:nvSpPr>
         <p:spPr>
           <a:xfrm>
-            <a:off x="3268980" y="1143000"/>
-            <a:ext cx="2606040" cy="1600200"/>
+            <a:off x="3268980" y="1097280"/>
+            <a:ext cx="2606040" cy="1691640"/>
           </a:xfrm>
           <a:prstGeom prst="roundRect">
             <a:avLst>
-              <a:gd name="adj" fmla="val 4571"/>
+              <a:gd name="adj" fmla="val 4324"/>
             </a:avLst>
           </a:prstGeom>
           <a:solidFill>
@@ -3129,7 +3141,7 @@
         </p:nvSpPr>
         <p:spPr>
           <a:xfrm>
-            <a:off x="3451860" y="1325880"/>
+            <a:off x="3451860" y="1280160"/>
             <a:ext cx="502920" cy="502920"/>
           </a:xfrm>
           <a:prstGeom prst="ellipse">
@@ -3162,7 +3174,7 @@
         </p:blipFill>
         <p:spPr>
           <a:xfrm>
-            <a:off x="3570732" y="1444752"/>
+            <a:off x="3570732" y="1399032"/>
             <a:ext cx="265176" cy="265176"/>
           </a:xfrm>
           <a:prstGeom prst="rect">
@@ -3178,8 +3190,8 @@
         </p:nvSpPr>
         <p:spPr>
           <a:xfrm>
-            <a:off x="4073652" y="1325880"/>
-            <a:ext cx="1691640" cy="502920"/>
+            <a:off x="4046220" y="1234440"/>
+            <a:ext cx="1737360" cy="594360"/>
           </a:xfrm>
           <a:prstGeom prst="rect">
             <a:avLst/>
@@ -3195,14 +3207,14 @@
               <a:buNone/>
             </a:pPr>
             <a:r>
-              <a:rPr lang="en-US" sz="1400" b="1" dirty="0">
+              <a:rPr lang="en-US" sz="1700" b="1" dirty="0">
                 <a:solidFill>
                   <a:schemeClr val="tx2"/>
                 </a:solidFill>
               </a:rPr>
               <a:t>生活サポート</a:t>
             </a:r>
-            <a:endParaRPr lang="en-US" sz="1400" dirty="0"/>
+            <a:endParaRPr lang="en-US" sz="1700" dirty="0"/>
           </a:p>
         </p:txBody>
       </p:sp>
@@ -3214,8 +3226,8 @@
         </p:nvSpPr>
         <p:spPr>
           <a:xfrm>
-            <a:off x="3451860" y="1947672"/>
-            <a:ext cx="2240280" cy="685800"/>
+            <a:off x="3451860" y="1901952"/>
+            <a:ext cx="2286000" cy="777240"/>
           </a:xfrm>
           <a:prstGeom prst="rect">
             <a:avLst/>
@@ -3231,14 +3243,14 @@
               <a:buNone/>
             </a:pPr>
             <a:r>
-              <a:rPr lang="en-US" sz="1200" dirty="0">
+              <a:rPr lang="en-US" sz="1500" dirty="0">
                 <a:solidFill>
                   <a:schemeClr val="tx1"/>
                 </a:solidFill>
               </a:rPr>
-              <a:t>騒音などのトラブルは、まず双方の話を聞いて解決へ</a:t>
-            </a:r>
-            <a:endParaRPr lang="en-US" sz="1200" dirty="0"/>
+              <a:t>騒音などのトラブルは双方の話を聞いて解決</a:t>
+            </a:r>
+            <a:endParaRPr lang="en-US" sz="1500" dirty="0"/>
           </a:p>
         </p:txBody>
       </p:sp>
@@ -3250,12 +3262,12 @@
         </p:nvSpPr>
         <p:spPr>
           <a:xfrm>
-            <a:off x="6080760" y="1143000"/>
-            <a:ext cx="2606040" cy="1600200"/>
+            <a:off x="6080760" y="1097280"/>
+            <a:ext cx="2606040" cy="1691640"/>
           </a:xfrm>
           <a:prstGeom prst="roundRect">
             <a:avLst>
-              <a:gd name="adj" fmla="val 4571"/>
+              <a:gd name="adj" fmla="val 4324"/>
             </a:avLst>
           </a:prstGeom>
           <a:solidFill>
@@ -3284,7 +3296,7 @@
         </p:nvSpPr>
         <p:spPr>
           <a:xfrm>
-            <a:off x="6263640" y="1325880"/>
+            <a:off x="6263640" y="1280160"/>
             <a:ext cx="502920" cy="502920"/>
           </a:xfrm>
           <a:prstGeom prst="ellipse">
@@ -3317,7 +3329,7 @@
         </p:blipFill>
         <p:spPr>
           <a:xfrm>
-            <a:off x="6382512" y="1444752"/>
+            <a:off x="6382512" y="1399032"/>
             <a:ext cx="265176" cy="265176"/>
           </a:xfrm>
           <a:prstGeom prst="rect">
@@ -3333,8 +3345,8 @@
         </p:nvSpPr>
         <p:spPr>
           <a:xfrm>
-            <a:off x="6885432" y="1325880"/>
-            <a:ext cx="1691640" cy="502920"/>
+            <a:off x="6858000" y="1234440"/>
+            <a:ext cx="1737360" cy="594360"/>
           </a:xfrm>
           <a:prstGeom prst="rect">
             <a:avLst/>
@@ -3350,14 +3362,14 @@
               <a:buNone/>
             </a:pPr>
             <a:r>
-              <a:rPr lang="en-US" sz="1400" b="1" dirty="0">
+              <a:rPr lang="en-US" sz="1700" b="1" dirty="0">
                 <a:solidFill>
                   <a:schemeClr val="tx2"/>
                 </a:solidFill>
               </a:rPr>
-              <a:t>寮母さんとの連携</a:t>
-            </a:r>
-            <a:endParaRPr lang="en-US" sz="1400" dirty="0"/>
+              <a:t>寮母さん連携</a:t>
+            </a:r>
+            <a:endParaRPr lang="en-US" sz="1700" dirty="0"/>
           </a:p>
         </p:txBody>
       </p:sp>
@@ -3369,8 +3381,8 @@
         </p:nvSpPr>
         <p:spPr>
           <a:xfrm>
-            <a:off x="6263640" y="1947672"/>
-            <a:ext cx="2240280" cy="685800"/>
+            <a:off x="6263640" y="1901952"/>
+            <a:ext cx="2286000" cy="777240"/>
           </a:xfrm>
           <a:prstGeom prst="rect">
             <a:avLst/>
@@ -3386,14 +3398,14 @@
               <a:buNone/>
             </a:pPr>
             <a:r>
-              <a:rPr lang="en-US" sz="1200" dirty="0">
+              <a:rPr lang="en-US" sz="1500" dirty="0">
                 <a:solidFill>
                   <a:schemeClr val="tx1"/>
                 </a:solidFill>
               </a:rPr>
-              <a:t>寮生の声を月1回のRAミーティングで共有・改善</a:t>
-            </a:r>
-            <a:endParaRPr lang="en-US" sz="1200" dirty="0"/>
+              <a:t>寮生の声を月1回のRAミーティングで共有</a:t>
+            </a:r>
+            <a:endParaRPr lang="en-US" sz="1500" dirty="0"/>
           </a:p>
         </p:txBody>
       </p:sp>
@@ -3406,11 +3418,11 @@
         <p:spPr>
           <a:xfrm>
             <a:off x="457200" y="2971800"/>
-            <a:ext cx="2606040" cy="1600200"/>
+            <a:ext cx="2606040" cy="1691640"/>
           </a:xfrm>
           <a:prstGeom prst="roundRect">
             <a:avLst>
-              <a:gd name="adj" fmla="val 4571"/>
+              <a:gd name="adj" fmla="val 4324"/>
             </a:avLst>
           </a:prstGeom>
           <a:solidFill>
@@ -3488,8 +3500,8 @@
         </p:nvSpPr>
         <p:spPr>
           <a:xfrm>
-            <a:off x="1261872" y="3154680"/>
-            <a:ext cx="1691640" cy="502920"/>
+            <a:off x="1234440" y="3108960"/>
+            <a:ext cx="1737360" cy="594360"/>
           </a:xfrm>
           <a:prstGeom prst="rect">
             <a:avLst/>
@@ -3505,14 +3517,14 @@
               <a:buNone/>
             </a:pPr>
             <a:r>
-              <a:rPr lang="en-US" sz="1400" b="1" dirty="0">
+              <a:rPr lang="en-US" sz="1700" b="1" dirty="0">
                 <a:solidFill>
                   <a:schemeClr val="tx2"/>
                 </a:solidFill>
               </a:rPr>
               <a:t>入退寮サポート</a:t>
             </a:r>
-            <a:endParaRPr lang="en-US" sz="1400" dirty="0"/>
+            <a:endParaRPr lang="en-US" sz="1700" dirty="0"/>
           </a:p>
         </p:txBody>
       </p:sp>
@@ -3525,7 +3537,7 @@
         <p:spPr>
           <a:xfrm>
             <a:off x="640080" y="3776472"/>
-            <a:ext cx="2240280" cy="685800"/>
+            <a:ext cx="2286000" cy="777240"/>
           </a:xfrm>
           <a:prstGeom prst="rect">
             <a:avLst/>
@@ -3541,14 +3553,14 @@
               <a:buNone/>
             </a:pPr>
             <a:r>
-              <a:rPr lang="en-US" sz="1200" dirty="0">
+              <a:rPr lang="en-US" sz="1500" dirty="0">
                 <a:solidFill>
                   <a:schemeClr val="tx1"/>
                 </a:solidFill>
               </a:rPr>
-              <a:t>新寮生の案内や、寮生活のルール説明を担当</a:t>
-            </a:r>
-            <a:endParaRPr lang="en-US" sz="1200" dirty="0"/>
+              <a:t>新寮生の案内や寮のルール説明</a:t>
+            </a:r>
+            <a:endParaRPr lang="en-US" sz="1500" dirty="0"/>
           </a:p>
         </p:txBody>
       </p:sp>
@@ -3561,11 +3573,11 @@
         <p:spPr>
           <a:xfrm>
             <a:off x="3268980" y="2971800"/>
-            <a:ext cx="2606040" cy="1600200"/>
+            <a:ext cx="2606040" cy="1691640"/>
           </a:xfrm>
           <a:prstGeom prst="roundRect">
             <a:avLst>
-              <a:gd name="adj" fmla="val 4571"/>
+              <a:gd name="adj" fmla="val 4324"/>
             </a:avLst>
           </a:prstGeom>
           <a:solidFill>
@@ -3643,8 +3655,8 @@
         </p:nvSpPr>
         <p:spPr>
           <a:xfrm>
-            <a:off x="4073652" y="3154680"/>
-            <a:ext cx="1691640" cy="502920"/>
+            <a:off x="4046220" y="3108960"/>
+            <a:ext cx="1737360" cy="594360"/>
           </a:xfrm>
           <a:prstGeom prst="rect">
             <a:avLst/>
@@ -3660,14 +3672,14 @@
               <a:buNone/>
             </a:pPr>
             <a:r>
-              <a:rPr lang="en-US" sz="1400" b="1" dirty="0">
+              <a:rPr lang="en-US" sz="1700" b="1" dirty="0">
                 <a:solidFill>
                   <a:schemeClr val="tx2"/>
                 </a:solidFill>
               </a:rPr>
               <a:t>報告書・議事録</a:t>
             </a:r>
-            <a:endParaRPr lang="en-US" sz="1400" dirty="0"/>
+            <a:endParaRPr lang="en-US" sz="1700" dirty="0"/>
           </a:p>
         </p:txBody>
       </p:sp>
@@ -3680,7 +3692,7 @@
         <p:spPr>
           <a:xfrm>
             <a:off x="3451860" y="3776472"/>
-            <a:ext cx="2240280" cy="685800"/>
+            <a:ext cx="2286000" cy="777240"/>
           </a:xfrm>
           <a:prstGeom prst="rect">
             <a:avLst/>
@@ -3696,14 +3708,14 @@
               <a:buNone/>
             </a:pPr>
             <a:r>
-              <a:rPr lang="en-US" sz="1200" dirty="0">
+              <a:rPr lang="en-US" sz="1500" dirty="0">
                 <a:solidFill>
                   <a:schemeClr val="tx1"/>
                 </a:solidFill>
               </a:rPr>
-              <a:t>業務報告書やミーティング議事録をまとめる</a:t>
-            </a:r>
-            <a:endParaRPr lang="en-US" sz="1200" dirty="0"/>
+              <a:t>業務報告書や議事録をまとめる</a:t>
+            </a:r>
+            <a:endParaRPr lang="en-US" sz="1500" dirty="0"/>
           </a:p>
         </p:txBody>
       </p:sp>
@@ -3716,11 +3728,11 @@
         <p:spPr>
           <a:xfrm>
             <a:off x="6080760" y="2971800"/>
-            <a:ext cx="2606040" cy="1600200"/>
+            <a:ext cx="2606040" cy="1691640"/>
           </a:xfrm>
           <a:prstGeom prst="roundRect">
             <a:avLst>
-              <a:gd name="adj" fmla="val 4571"/>
+              <a:gd name="adj" fmla="val 4324"/>
             </a:avLst>
           </a:prstGeom>
           <a:solidFill>
@@ -3798,8 +3810,8 @@
         </p:nvSpPr>
         <p:spPr>
           <a:xfrm>
-            <a:off x="6885432" y="3154680"/>
-            <a:ext cx="1691640" cy="502920"/>
+            <a:off x="6858000" y="3108960"/>
+            <a:ext cx="1737360" cy="594360"/>
           </a:xfrm>
           <a:prstGeom prst="rect">
             <a:avLst/>
@@ -3815,14 +3827,14 @@
               <a:buNone/>
             </a:pPr>
             <a:r>
-              <a:rPr lang="en-US" sz="1400" b="1" dirty="0">
+              <a:rPr lang="en-US" sz="1700" b="1" dirty="0">
                 <a:solidFill>
                   <a:schemeClr val="tx2"/>
                 </a:solidFill>
               </a:rPr>
               <a:t>防災・緊急対応</a:t>
             </a:r>
-            <a:endParaRPr lang="en-US" sz="1400" dirty="0"/>
+            <a:endParaRPr lang="en-US" sz="1700" dirty="0"/>
           </a:p>
         </p:txBody>
       </p:sp>
@@ -3835,7 +3847,7 @@
         <p:spPr>
           <a:xfrm>
             <a:off x="6263640" y="3776472"/>
-            <a:ext cx="2240280" cy="685800"/>
+            <a:ext cx="2286000" cy="777240"/>
           </a:xfrm>
           <a:prstGeom prst="rect">
             <a:avLst/>
@@ -3851,14 +3863,14 @@
               <a:buNone/>
             </a:pPr>
             <a:r>
-              <a:rPr lang="en-US" sz="1200" dirty="0">
+              <a:rPr lang="en-US" sz="1500" dirty="0">
                 <a:solidFill>
                   <a:schemeClr val="tx1"/>
                 </a:solidFill>
               </a:rPr>
-              <a:t>防災訓練では率先して避難誘導を行う</a:t>
-            </a:r>
-            <a:endParaRPr lang="en-US" sz="1200" dirty="0"/>
+              <a:t>防災訓練で率先して避難誘導</a:t>
+            </a:r>
+            <a:endParaRPr lang="en-US" sz="1500" dirty="0"/>
           </a:p>
         </p:txBody>
       </p:sp>
@@ -3874,7 +3886,7 @@
         </p:nvSpPr>
         <p:spPr>
           <a:xfrm>
-            <a:off x="8321040" y="4754880"/>
+            <a:off x="8321040" y="4800600"/>
             <a:ext cx="457200" cy="274320"/>
           </a:xfrm>
           <a:prstGeom prst="rect">
@@ -3890,7 +3902,7 @@
           <a:bodyPr/>
           <a:lstStyle>
             <a:lvl1pPr>
-              <a:defRPr sz="1000">
+              <a:defRPr sz="1100">
                 <a:solidFill>
                   <a:schemeClr val="accent4"/>
                 </a:solidFill>
@@ -3942,8 +3954,8 @@
         </p:nvSpPr>
         <p:spPr>
           <a:xfrm>
-            <a:off x="457200" y="274320"/>
-            <a:ext cx="8229600" cy="640080"/>
+            <a:off x="457200" y="228600"/>
+            <a:ext cx="8229600" cy="685800"/>
           </a:xfrm>
           <a:prstGeom prst="rect">
             <a:avLst/>
@@ -3959,14 +3971,14 @@
               <a:buNone/>
             </a:pPr>
             <a:r>
-              <a:rPr lang="en-US" sz="2800" b="1" dirty="0">
+              <a:rPr lang="en-US" sz="3400" b="1" dirty="0">
                 <a:solidFill>
                   <a:schemeClr val="tx2"/>
                 </a:solidFill>
               </a:rPr>
               <a:t>イベント紹介：寮生活を楽しく！</a:t>
             </a:r>
-            <a:endParaRPr lang="en-US" sz="2800" dirty="0"/>
+            <a:endParaRPr lang="en-US" sz="3400" dirty="0"/>
           </a:p>
         </p:txBody>
       </p:sp>
@@ -3985,8 +3997,8 @@
         </p:blipFill>
         <p:spPr>
           <a:xfrm>
-            <a:off x="457200" y="1097280"/>
-            <a:ext cx="3977640" cy="2103120"/>
+            <a:off x="457200" y="1051560"/>
+            <a:ext cx="3977640" cy="1874520"/>
           </a:xfrm>
           <a:prstGeom prst="rect">
             <a:avLst/>
@@ -4001,8 +4013,8 @@
         </p:nvSpPr>
         <p:spPr>
           <a:xfrm>
-            <a:off x="457200" y="3291840"/>
-            <a:ext cx="3977640" cy="320040"/>
+            <a:off x="457200" y="3017520"/>
+            <a:ext cx="3977640" cy="365760"/>
           </a:xfrm>
           <a:prstGeom prst="rect">
             <a:avLst/>
@@ -4018,14 +4030,14 @@
               <a:buNone/>
             </a:pPr>
             <a:r>
-              <a:rPr lang="en-US" sz="1500" b="1" dirty="0">
+              <a:rPr lang="en-US" sz="1900" b="1" dirty="0">
                 <a:solidFill>
                   <a:schemeClr val="tx2"/>
                 </a:solidFill>
               </a:rPr>
               <a:t>4月　新入生歓迎会</a:t>
             </a:r>
-            <a:endParaRPr lang="en-US" sz="1500" dirty="0"/>
+            <a:endParaRPr lang="en-US" sz="1900" dirty="0"/>
           </a:p>
         </p:txBody>
       </p:sp>
@@ -4037,8 +4049,8 @@
         </p:nvSpPr>
         <p:spPr>
           <a:xfrm>
-            <a:off x="457200" y="3611880"/>
-            <a:ext cx="3977640" cy="457200"/>
+            <a:off x="457200" y="3401568"/>
+            <a:ext cx="3977640" cy="594360"/>
           </a:xfrm>
           <a:prstGeom prst="rect">
             <a:avLst/>
@@ -4054,14 +4066,14 @@
               <a:buNone/>
             </a:pPr>
             <a:r>
-              <a:rPr lang="en-US" sz="1200" dirty="0">
+              <a:rPr lang="en-US" sz="1500" dirty="0">
                 <a:solidFill>
                   <a:schemeClr val="tx1"/>
                 </a:solidFill>
               </a:rPr>
-              <a:t>新寮生と在寮生が顔を合わせる最初のイベント。RAが企画・司会を担当</a:t>
-            </a:r>
-            <a:endParaRPr lang="en-US" sz="1200" dirty="0"/>
+              <a:t>新寮生と在寮生の最初の交流の場。RAが企画・司会を担当</a:t>
+            </a:r>
+            <a:endParaRPr lang="en-US" sz="1500" dirty="0"/>
           </a:p>
         </p:txBody>
       </p:sp>
@@ -4080,8 +4092,8 @@
         </p:blipFill>
         <p:spPr>
           <a:xfrm>
-            <a:off x="4709160" y="1097280"/>
-            <a:ext cx="3977640" cy="2103120"/>
+            <a:off x="4709160" y="1051560"/>
+            <a:ext cx="3977640" cy="1874520"/>
           </a:xfrm>
           <a:prstGeom prst="rect">
             <a:avLst/>
@@ -4096,8 +4108,8 @@
         </p:nvSpPr>
         <p:spPr>
           <a:xfrm>
-            <a:off x="4709160" y="3291840"/>
-            <a:ext cx="3977640" cy="320040"/>
+            <a:off x="4709160" y="3017520"/>
+            <a:ext cx="3977640" cy="365760"/>
           </a:xfrm>
           <a:prstGeom prst="rect">
             <a:avLst/>
@@ -4113,14 +4125,14 @@
               <a:buNone/>
             </a:pPr>
             <a:r>
-              <a:rPr lang="en-US" sz="1500" b="1" dirty="0">
+              <a:rPr lang="en-US" sz="1900" b="1" dirty="0">
                 <a:solidFill>
                   <a:schemeClr val="tx2"/>
                 </a:solidFill>
               </a:rPr>
               <a:t>5月　クリーン大作戦</a:t>
             </a:r>
-            <a:endParaRPr lang="en-US" sz="1500" dirty="0"/>
+            <a:endParaRPr lang="en-US" sz="1900" dirty="0"/>
           </a:p>
         </p:txBody>
       </p:sp>
@@ -4132,8 +4144,8 @@
         </p:nvSpPr>
         <p:spPr>
           <a:xfrm>
-            <a:off x="4709160" y="3611880"/>
-            <a:ext cx="3977640" cy="457200"/>
+            <a:off x="4709160" y="3401568"/>
+            <a:ext cx="3977640" cy="594360"/>
           </a:xfrm>
           <a:prstGeom prst="rect">
             <a:avLst/>
@@ -4149,14 +4161,14 @@
               <a:buNone/>
             </a:pPr>
             <a:r>
-              <a:rPr lang="en-US" sz="1200" dirty="0">
+              <a:rPr lang="en-US" sz="1500" dirty="0">
                 <a:solidFill>
                   <a:schemeClr val="tx1"/>
                 </a:solidFill>
               </a:rPr>
-              <a:t>寮生全員で寮の周辺を清掃。地域の方との関係づくりにも</a:t>
-            </a:r>
-            <a:endParaRPr lang="en-US" sz="1200" dirty="0"/>
+              <a:t>寮生全員で寮の周辺を清掃。地域との関係づくりにも</a:t>
+            </a:r>
+            <a:endParaRPr lang="en-US" sz="1500" dirty="0"/>
           </a:p>
         </p:txBody>
       </p:sp>
@@ -4168,12 +4180,12 @@
         </p:nvSpPr>
         <p:spPr>
           <a:xfrm>
-            <a:off x="457200" y="4206240"/>
-            <a:ext cx="8229600" cy="457200"/>
+            <a:off x="457200" y="4114800"/>
+            <a:ext cx="8229600" cy="594360"/>
           </a:xfrm>
           <a:prstGeom prst="roundRect">
             <a:avLst>
-              <a:gd name="adj" fmla="val 16000"/>
+              <a:gd name="adj" fmla="val 12308"/>
             </a:avLst>
           </a:prstGeom>
           <a:solidFill>
@@ -4203,8 +4215,8 @@
         </p:blipFill>
         <p:spPr>
           <a:xfrm>
-            <a:off x="621792" y="4297680"/>
-            <a:ext cx="274320" cy="274320"/>
+            <a:off x="640080" y="4251960"/>
+            <a:ext cx="320040" cy="320040"/>
           </a:xfrm>
           <a:prstGeom prst="rect">
             <a:avLst/>
@@ -4219,8 +4231,8 @@
         </p:nvSpPr>
         <p:spPr>
           <a:xfrm>
-            <a:off x="1005840" y="4206240"/>
-            <a:ext cx="7589520" cy="457200"/>
+            <a:off x="1143000" y="4114800"/>
+            <a:ext cx="7406640" cy="594360"/>
           </a:xfrm>
           <a:prstGeom prst="rect">
             <a:avLst/>
@@ -4236,7 +4248,7 @@
               <a:buNone/>
             </a:pPr>
             <a:r>
-              <a:rPr lang="en-US" sz="1200" b="1" dirty="0">
+              <a:rPr lang="en-US" sz="1700" b="1" dirty="0">
                 <a:solidFill>
                   <a:schemeClr val="tx2"/>
                 </a:solidFill>
@@ -4247,14 +4259,14 @@
               <a:buNone/>
             </a:pPr>
             <a:r>
-              <a:rPr lang="en-US" sz="1200" dirty="0">
+              <a:rPr lang="en-US" sz="1700" dirty="0">
                 <a:solidFill>
                   <a:schemeClr val="tx1"/>
                 </a:solidFill>
               </a:rPr>
-              <a:t>ビンゴ大会、防災訓練、秋のクリーン大作戦など。RAのアイデアで新しい企画もできます</a:t>
-            </a:r>
-            <a:endParaRPr lang="en-US" sz="1200" dirty="0"/>
+              <a:t>ビンゴ大会、防災訓練など。RAのアイデアで新企画も！</a:t>
+            </a:r>
+            <a:endParaRPr lang="en-US" sz="1700" dirty="0"/>
           </a:p>
         </p:txBody>
       </p:sp>
@@ -4270,7 +4282,7 @@
         </p:nvSpPr>
         <p:spPr>
           <a:xfrm>
-            <a:off x="8321040" y="4754880"/>
+            <a:off x="8321040" y="4800600"/>
             <a:ext cx="457200" cy="274320"/>
           </a:xfrm>
           <a:prstGeom prst="rect">
@@ -4286,7 +4298,7 @@
           <a:bodyPr/>
           <a:lstStyle>
             <a:lvl1pPr>
-              <a:defRPr sz="1000">
+              <a:defRPr sz="1100">
                 <a:solidFill>
                   <a:schemeClr val="accent4"/>
                 </a:solidFill>
@@ -4338,8 +4350,8 @@
         </p:nvSpPr>
         <p:spPr>
           <a:xfrm>
-            <a:off x="457200" y="274320"/>
-            <a:ext cx="8229600" cy="640080"/>
+            <a:off x="457200" y="228600"/>
+            <a:ext cx="8229600" cy="685800"/>
           </a:xfrm>
           <a:prstGeom prst="rect">
             <a:avLst/>
@@ -4355,14 +4367,14 @@
               <a:buNone/>
             </a:pPr>
             <a:r>
-              <a:rPr lang="en-US" sz="2800" b="1" dirty="0">
+              <a:rPr lang="en-US" sz="3400" b="1" dirty="0">
                 <a:solidFill>
                   <a:schemeClr val="tx2"/>
                 </a:solidFill>
               </a:rPr>
-              <a:t>RAをやって良かったこと・大変だったこと</a:t>
-            </a:r>
-            <a:endParaRPr lang="en-US" sz="2800" dirty="0"/>
+              <a:t>良かったこと・大変だったこと</a:t>
+            </a:r>
+            <a:endParaRPr lang="en-US" sz="3400" dirty="0"/>
           </a:p>
         </p:txBody>
       </p:sp>
@@ -4374,12 +4386,12 @@
         </p:nvSpPr>
         <p:spPr>
           <a:xfrm>
-            <a:off x="457200" y="1143000"/>
-            <a:ext cx="4572000" cy="3520440"/>
+            <a:off x="457200" y="1097280"/>
+            <a:ext cx="4572000" cy="3611880"/>
           </a:xfrm>
           <a:prstGeom prst="roundRect">
             <a:avLst>
-              <a:gd name="adj" fmla="val 2078"/>
+              <a:gd name="adj" fmla="val 2025"/>
             </a:avLst>
           </a:prstGeom>
           <a:solidFill>
@@ -4408,8 +4420,8 @@
         </p:nvSpPr>
         <p:spPr>
           <a:xfrm>
-            <a:off x="685800" y="1325880"/>
-            <a:ext cx="502920" cy="502920"/>
+            <a:off x="685800" y="1261872"/>
+            <a:ext cx="548640" cy="548640"/>
           </a:xfrm>
           <a:prstGeom prst="ellipse">
             <a:avLst/>
@@ -4441,8 +4453,8 @@
         </p:blipFill>
         <p:spPr>
           <a:xfrm>
-            <a:off x="809244" y="1449324"/>
-            <a:ext cx="256032" cy="256032"/>
+            <a:off x="822960" y="1399032"/>
+            <a:ext cx="274320" cy="274320"/>
           </a:xfrm>
           <a:prstGeom prst="rect">
             <a:avLst/>
@@ -4457,8 +4469,8 @@
         </p:nvSpPr>
         <p:spPr>
           <a:xfrm>
-            <a:off x="1325880" y="1325880"/>
-            <a:ext cx="3566160" cy="502920"/>
+            <a:off x="1371600" y="1261872"/>
+            <a:ext cx="3520440" cy="548640"/>
           </a:xfrm>
           <a:prstGeom prst="rect">
             <a:avLst/>
@@ -4474,14 +4486,14 @@
               <a:buNone/>
             </a:pPr>
             <a:r>
-              <a:rPr lang="en-US" sz="1800" b="1" dirty="0">
+              <a:rPr lang="en-US" sz="2200" b="1" dirty="0">
                 <a:solidFill>
                   <a:schemeClr val="tx2"/>
                 </a:solidFill>
               </a:rPr>
               <a:t>良かったこと</a:t>
             </a:r>
-            <a:endParaRPr lang="en-US" sz="1800" dirty="0"/>
+            <a:endParaRPr lang="en-US" sz="2200" dirty="0"/>
           </a:p>
         </p:txBody>
       </p:sp>
@@ -4493,8 +4505,8 @@
         </p:nvSpPr>
         <p:spPr>
           <a:xfrm>
-            <a:off x="685800" y="2011680"/>
-            <a:ext cx="4114800" cy="2468880"/>
+            <a:off x="685800" y="1965960"/>
+            <a:ext cx="4206240" cy="2606040"/>
           </a:xfrm>
           <a:prstGeom prst="rect">
             <a:avLst/>
@@ -4508,92 +4520,92 @@
           <a:p>
             <a:pPr marL="342900" indent="-342900">
               <a:spcAft>
-                <a:spcPts val="1400"/>
+                <a:spcPts val="1200"/>
               </a:spcAft>
               <a:buSzPct val="100000"/>
               <a:buChar char="•"/>
             </a:pPr>
             <a:r>
-              <a:rPr lang="en-US" sz="1400" dirty="0">
+              <a:rPr lang="en-US" sz="1800" dirty="0">
                 <a:solidFill>
                   <a:schemeClr val="tx1"/>
                 </a:solidFill>
               </a:rPr>
               <a:t>学年・学科をこえた仲間ができた</a:t>
             </a:r>
-            <a:endParaRPr lang="en-US" sz="1400" dirty="0"/>
+            <a:endParaRPr lang="en-US" sz="1800" dirty="0"/>
           </a:p>
           <a:p>
             <a:pPr marL="342900" indent="-342900">
               <a:spcAft>
-                <a:spcPts val="1400"/>
+                <a:spcPts val="1200"/>
               </a:spcAft>
               <a:buSzPct val="100000"/>
               <a:buChar char="•"/>
             </a:pPr>
             <a:r>
-              <a:rPr lang="en-US" sz="1400" dirty="0">
+              <a:rPr lang="en-US" sz="1800" dirty="0">
                 <a:solidFill>
                   <a:schemeClr val="tx1"/>
                 </a:solidFill>
               </a:rPr>
-              <a:t>寮生から「ありがとう」と言ってもらえる</a:t>
-            </a:r>
-            <a:endParaRPr lang="en-US" sz="1400" dirty="0"/>
+              <a:t>寮生から「ありがとう」と言われる</a:t>
+            </a:r>
+            <a:endParaRPr lang="en-US" sz="1800" dirty="0"/>
           </a:p>
           <a:p>
             <a:pPr marL="342900" indent="-342900">
               <a:spcAft>
-                <a:spcPts val="1400"/>
+                <a:spcPts val="1200"/>
               </a:spcAft>
               <a:buSzPct val="100000"/>
               <a:buChar char="•"/>
             </a:pPr>
             <a:r>
-              <a:rPr lang="en-US" sz="1400" dirty="0">
+              <a:rPr lang="en-US" sz="1800" dirty="0">
                 <a:solidFill>
                   <a:schemeClr val="tx1"/>
                 </a:solidFill>
               </a:rPr>
-              <a:t>人前で話す力・調整する力が身についた</a:t>
-            </a:r>
-            <a:endParaRPr lang="en-US" sz="1400" dirty="0"/>
+              <a:t>人前で話す力・調整する力がついた</a:t>
+            </a:r>
+            <a:endParaRPr lang="en-US" sz="1800" dirty="0"/>
           </a:p>
           <a:p>
             <a:pPr marL="342900" indent="-342900">
               <a:spcAft>
-                <a:spcPts val="1400"/>
+                <a:spcPts val="1200"/>
               </a:spcAft>
               <a:buSzPct val="100000"/>
               <a:buChar char="•"/>
             </a:pPr>
             <a:r>
-              <a:rPr lang="en-US" sz="1400" dirty="0">
+              <a:rPr lang="en-US" sz="1800" dirty="0">
                 <a:solidFill>
                   <a:schemeClr val="tx1"/>
                 </a:solidFill>
               </a:rPr>
-              <a:t>寮生の顔と名前がわかり、寮が居心地よくなった</a:t>
-            </a:r>
-            <a:endParaRPr lang="en-US" sz="1400" dirty="0"/>
+              <a:t>寮がもっと居心地よくなった</a:t>
+            </a:r>
+            <a:endParaRPr lang="en-US" sz="1800" dirty="0"/>
           </a:p>
           <a:p>
             <a:pPr marL="342900" indent="-342900">
               <a:spcAft>
-                <a:spcPts val="1400"/>
+                <a:spcPts val="1200"/>
               </a:spcAft>
               <a:buSzPct val="100000"/>
               <a:buChar char="•"/>
             </a:pPr>
             <a:r>
-              <a:rPr lang="en-US" sz="1400" dirty="0">
+              <a:rPr lang="en-US" sz="1800" dirty="0">
                 <a:solidFill>
                   <a:schemeClr val="tx1"/>
                 </a:solidFill>
               </a:rPr>
-              <a:t>寮費免除で、学業に集中しやすい</a:t>
-            </a:r>
-            <a:endParaRPr lang="en-US" sz="1400" dirty="0"/>
+              <a:t>寮費免除で学業に集中しやすい</a:t>
+            </a:r>
+            <a:endParaRPr lang="en-US" sz="1800" dirty="0"/>
           </a:p>
         </p:txBody>
       </p:sp>
@@ -4605,12 +4617,12 @@
         </p:nvSpPr>
         <p:spPr>
           <a:xfrm>
-            <a:off x="5303520" y="1143000"/>
-            <a:ext cx="3383280" cy="3520440"/>
+            <a:off x="5257800" y="1097280"/>
+            <a:ext cx="3429000" cy="3611880"/>
           </a:xfrm>
           <a:prstGeom prst="roundRect">
             <a:avLst>
-              <a:gd name="adj" fmla="val 2162"/>
+              <a:gd name="adj" fmla="val 2133"/>
             </a:avLst>
           </a:prstGeom>
           <a:solidFill>
@@ -4639,8 +4651,8 @@
         </p:nvSpPr>
         <p:spPr>
           <a:xfrm>
-            <a:off x="5532120" y="1325880"/>
-            <a:ext cx="502920" cy="502920"/>
+            <a:off x="5486400" y="1261872"/>
+            <a:ext cx="548640" cy="548640"/>
           </a:xfrm>
           <a:prstGeom prst="ellipse">
             <a:avLst/>
@@ -4672,8 +4684,8 @@
         </p:blipFill>
         <p:spPr>
           <a:xfrm>
-            <a:off x="5655564" y="1449324"/>
-            <a:ext cx="256032" cy="256032"/>
+            <a:off x="5623560" y="1399032"/>
+            <a:ext cx="274320" cy="274320"/>
           </a:xfrm>
           <a:prstGeom prst="rect">
             <a:avLst/>
@@ -4688,8 +4700,8 @@
         </p:nvSpPr>
         <p:spPr>
           <a:xfrm>
-            <a:off x="6172200" y="1325880"/>
-            <a:ext cx="2377440" cy="502920"/>
+            <a:off x="6172200" y="1261872"/>
+            <a:ext cx="2377440" cy="548640"/>
           </a:xfrm>
           <a:prstGeom prst="rect">
             <a:avLst/>
@@ -4705,14 +4717,14 @@
               <a:buNone/>
             </a:pPr>
             <a:r>
-              <a:rPr lang="en-US" sz="1800" b="1" dirty="0">
+              <a:rPr lang="en-US" sz="2200" b="1" dirty="0">
                 <a:solidFill>
                   <a:schemeClr val="tx2"/>
                 </a:solidFill>
               </a:rPr>
               <a:t>大変だったこと</a:t>
             </a:r>
-            <a:endParaRPr lang="en-US" sz="1800" dirty="0"/>
+            <a:endParaRPr lang="en-US" sz="2200" dirty="0"/>
           </a:p>
         </p:txBody>
       </p:sp>
@@ -4724,8 +4736,8 @@
         </p:nvSpPr>
         <p:spPr>
           <a:xfrm>
-            <a:off x="5532120" y="2011680"/>
-            <a:ext cx="2926080" cy="1600200"/>
+            <a:off x="5486400" y="1965960"/>
+            <a:ext cx="3063240" cy="1463040"/>
           </a:xfrm>
           <a:prstGeom prst="rect">
             <a:avLst/>
@@ -4739,56 +4751,56 @@
           <a:p>
             <a:pPr marL="342900" indent="-342900">
               <a:spcAft>
-                <a:spcPts val="1400"/>
+                <a:spcPts val="1200"/>
               </a:spcAft>
               <a:buSzPct val="100000"/>
               <a:buChar char="•"/>
             </a:pPr>
             <a:r>
-              <a:rPr lang="en-US" sz="1400" dirty="0">
+              <a:rPr lang="en-US" sz="1800" dirty="0">
                 <a:solidFill>
                   <a:schemeClr val="tx1"/>
                 </a:solidFill>
               </a:rPr>
               <a:t>学業・課題との両立</a:t>
             </a:r>
-            <a:endParaRPr lang="en-US" sz="1400" dirty="0"/>
+            <a:endParaRPr lang="en-US" sz="1800" dirty="0"/>
           </a:p>
           <a:p>
             <a:pPr marL="342900" indent="-342900">
               <a:spcAft>
-                <a:spcPts val="1400"/>
+                <a:spcPts val="1200"/>
               </a:spcAft>
               <a:buSzPct val="100000"/>
               <a:buChar char="•"/>
             </a:pPr>
             <a:r>
-              <a:rPr lang="en-US" sz="1400" dirty="0">
+              <a:rPr lang="en-US" sz="1800" dirty="0">
                 <a:solidFill>
                   <a:schemeClr val="tx1"/>
                 </a:solidFill>
               </a:rPr>
-              <a:t>寮生に注意をしなければならない場面</a:t>
-            </a:r>
-            <a:endParaRPr lang="en-US" sz="1400" dirty="0"/>
+              <a:t>寮生に注意する場面</a:t>
+            </a:r>
+            <a:endParaRPr lang="en-US" sz="1800" dirty="0"/>
           </a:p>
           <a:p>
             <a:pPr marL="342900" indent="-342900">
               <a:spcAft>
-                <a:spcPts val="1400"/>
+                <a:spcPts val="1200"/>
               </a:spcAft>
               <a:buSzPct val="100000"/>
               <a:buChar char="•"/>
             </a:pPr>
             <a:r>
-              <a:rPr lang="en-US" sz="1400" dirty="0">
+              <a:rPr lang="en-US" sz="1800" dirty="0">
                 <a:solidFill>
                   <a:schemeClr val="tx1"/>
                 </a:solidFill>
               </a:rPr>
-              <a:t>寮生の「お手本」であり続けること</a:t>
-            </a:r>
-            <a:endParaRPr lang="en-US" sz="1400" dirty="0"/>
+              <a:t>寮生のお手本でいること</a:t>
+            </a:r>
+            <a:endParaRPr lang="en-US" sz="1800" dirty="0"/>
           </a:p>
         </p:txBody>
       </p:sp>
@@ -4800,8 +4812,8 @@
         </p:nvSpPr>
         <p:spPr>
           <a:xfrm>
-            <a:off x="5532120" y="3657600"/>
-            <a:ext cx="2971800" cy="822960"/>
+            <a:off x="5486400" y="3520440"/>
+            <a:ext cx="3017520" cy="1051560"/>
           </a:xfrm>
           <a:prstGeom prst="rect">
             <a:avLst/>
@@ -4817,7 +4829,7 @@
               <a:buNone/>
             </a:pPr>
             <a:r>
-              <a:rPr lang="en-US" sz="1300" b="1" dirty="0">
+              <a:rPr lang="en-US" sz="1600" b="1" dirty="0">
                 <a:solidFill>
                   <a:schemeClr val="accent2"/>
                 </a:solidFill>
@@ -4828,14 +4840,14 @@
               <a:buNone/>
             </a:pPr>
             <a:r>
-              <a:rPr lang="en-US" sz="1300" b="1" dirty="0">
+              <a:rPr lang="en-US" sz="1600" b="1" dirty="0">
                 <a:solidFill>
                   <a:schemeClr val="tx2"/>
                 </a:solidFill>
               </a:rPr>
               <a:t>一人で抱えず、RA仲間や寮母さんに相談すれば大丈夫！</a:t>
             </a:r>
-            <a:endParaRPr lang="en-US" sz="1300" dirty="0"/>
+            <a:endParaRPr lang="en-US" sz="1600" dirty="0"/>
           </a:p>
         </p:txBody>
       </p:sp>
@@ -4851,7 +4863,7 @@
         </p:nvSpPr>
         <p:spPr>
           <a:xfrm>
-            <a:off x="8321040" y="4754880"/>
+            <a:off x="8321040" y="4800600"/>
             <a:ext cx="457200" cy="274320"/>
           </a:xfrm>
           <a:prstGeom prst="rect">
@@ -4867,7 +4879,7 @@
           <a:bodyPr/>
           <a:lstStyle>
             <a:lvl1pPr>
-              <a:defRPr sz="1000">
+              <a:defRPr sz="1100">
                 <a:solidFill>
                   <a:schemeClr val="accent4"/>
                 </a:solidFill>
@@ -4917,8 +4929,8 @@
         </p:nvSpPr>
         <p:spPr>
           <a:xfrm>
-            <a:off x="548640" y="457200"/>
-            <a:ext cx="8046720" cy="365760"/>
+            <a:off x="457200" y="457200"/>
+            <a:ext cx="8229600" cy="411480"/>
           </a:xfrm>
           <a:prstGeom prst="rect">
             <a:avLst/>
@@ -4934,14 +4946,14 @@
               <a:buNone/>
             </a:pPr>
             <a:r>
-              <a:rPr lang="en-US" sz="1400" b="1" dirty="0">
+              <a:rPr lang="en-US" sz="1800" b="1" dirty="0">
                 <a:solidFill>
                   <a:schemeClr val="accent2"/>
                 </a:solidFill>
               </a:rPr>
               <a:t>応募を考えている皆さんへ</a:t>
             </a:r>
-            <a:endParaRPr lang="en-US" sz="1400" dirty="0"/>
+            <a:endParaRPr lang="en-US" sz="1800" dirty="0"/>
           </a:p>
         </p:txBody>
       </p:sp>
@@ -4955,8 +4967,8 @@
         </p:nvSpPr>
         <p:spPr>
           <a:xfrm>
-            <a:off x="548640" y="914400"/>
-            <a:ext cx="8046720" cy="1097280"/>
+            <a:off x="457200" y="914400"/>
+            <a:ext cx="8229600" cy="1097280"/>
           </a:xfrm>
           <a:prstGeom prst="rect">
             <a:avLst/>
@@ -4972,14 +4984,14 @@
               <a:buNone/>
             </a:pPr>
             <a:r>
-              <a:rPr lang="en-US" sz="3200" b="1" dirty="0">
+              <a:rPr lang="en-US" sz="3400" b="1" dirty="0">
                 <a:solidFill>
                   <a:schemeClr val="bg1"/>
                 </a:solidFill>
               </a:rPr>
               <a:t>一緒に、住みやすい寮をつくりませんか？</a:t>
             </a:r>
-            <a:endParaRPr lang="en-US" sz="3200" dirty="0"/>
+            <a:endParaRPr lang="en-US" sz="3400" dirty="0"/>
           </a:p>
         </p:txBody>
       </p:sp>
@@ -4991,8 +5003,8 @@
         </p:nvSpPr>
         <p:spPr>
           <a:xfrm>
-            <a:off x="548640" y="2331720"/>
-            <a:ext cx="548640" cy="548640"/>
+            <a:off x="457200" y="2194560"/>
+            <a:ext cx="594360" cy="594360"/>
           </a:xfrm>
           <a:prstGeom prst="ellipse">
             <a:avLst/>
@@ -5024,8 +5036,8 @@
         </p:blipFill>
         <p:spPr>
           <a:xfrm>
-            <a:off x="685800" y="2468880"/>
-            <a:ext cx="274320" cy="274320"/>
+            <a:off x="603504" y="2340864"/>
+            <a:ext cx="301752" cy="301752"/>
           </a:xfrm>
           <a:prstGeom prst="rect">
             <a:avLst/>
@@ -5040,8 +5052,8 @@
         </p:nvSpPr>
         <p:spPr>
           <a:xfrm>
-            <a:off x="548640" y="3017520"/>
-            <a:ext cx="2468880" cy="548640"/>
+            <a:off x="457200" y="2926080"/>
+            <a:ext cx="2651760" cy="411480"/>
           </a:xfrm>
           <a:prstGeom prst="rect">
             <a:avLst/>
@@ -5057,14 +5069,14 @@
               <a:buNone/>
             </a:pPr>
             <a:r>
-              <a:rPr lang="en-US" sz="1400" b="1" dirty="0">
+              <a:rPr lang="en-US" sz="1900" b="1" dirty="0">
                 <a:solidFill>
                   <a:schemeClr val="bg1"/>
                 </a:solidFill>
               </a:rPr>
               <a:t>特別なスキルは不要</a:t>
             </a:r>
-            <a:endParaRPr lang="en-US" sz="1400" dirty="0"/>
+            <a:endParaRPr lang="en-US" sz="1900" dirty="0"/>
           </a:p>
         </p:txBody>
       </p:sp>
@@ -5076,8 +5088,8 @@
         </p:nvSpPr>
         <p:spPr>
           <a:xfrm>
-            <a:off x="548640" y="3429000"/>
-            <a:ext cx="2468880" cy="548640"/>
+            <a:off x="457200" y="3383280"/>
+            <a:ext cx="2606040" cy="777240"/>
           </a:xfrm>
           <a:prstGeom prst="rect">
             <a:avLst/>
@@ -5093,14 +5105,14 @@
               <a:buNone/>
             </a:pPr>
             <a:r>
-              <a:rPr lang="en-US" sz="1200" dirty="0">
+              <a:rPr lang="en-US" sz="1500" dirty="0">
                 <a:solidFill>
                   <a:schemeClr val="bg2"/>
                 </a:solidFill>
               </a:rPr>
               <a:t>「寮をもっと良くしたい」気持ちがあれば十分です</a:t>
             </a:r>
-            <a:endParaRPr lang="en-US" sz="1200" dirty="0"/>
+            <a:endParaRPr lang="en-US" sz="1500" dirty="0"/>
           </a:p>
         </p:txBody>
       </p:sp>
@@ -5112,8 +5124,8 @@
         </p:nvSpPr>
         <p:spPr>
           <a:xfrm>
-            <a:off x="3291840" y="2331720"/>
-            <a:ext cx="548640" cy="548640"/>
+            <a:off x="3246120" y="2194560"/>
+            <a:ext cx="594360" cy="594360"/>
           </a:xfrm>
           <a:prstGeom prst="ellipse">
             <a:avLst/>
@@ -5145,8 +5157,8 @@
         </p:blipFill>
         <p:spPr>
           <a:xfrm>
-            <a:off x="3429000" y="2468880"/>
-            <a:ext cx="274320" cy="274320"/>
+            <a:off x="3392424" y="2340864"/>
+            <a:ext cx="301752" cy="301752"/>
           </a:xfrm>
           <a:prstGeom prst="rect">
             <a:avLst/>
@@ -5161,8 +5173,8 @@
         </p:nvSpPr>
         <p:spPr>
           <a:xfrm>
-            <a:off x="3291840" y="3017520"/>
-            <a:ext cx="2468880" cy="548640"/>
+            <a:off x="3246120" y="2926080"/>
+            <a:ext cx="2651760" cy="411480"/>
           </a:xfrm>
           <a:prstGeom prst="rect">
             <a:avLst/>
@@ -5178,14 +5190,14 @@
               <a:buNone/>
             </a:pPr>
             <a:r>
-              <a:rPr lang="en-US" sz="1400" b="1" dirty="0">
+              <a:rPr lang="en-US" sz="1900" b="1" dirty="0">
                 <a:solidFill>
                   <a:schemeClr val="bg1"/>
                 </a:solidFill>
               </a:rPr>
               <a:t>仲間とサポートがある</a:t>
             </a:r>
-            <a:endParaRPr lang="en-US" sz="1400" dirty="0"/>
+            <a:endParaRPr lang="en-US" sz="1900" dirty="0"/>
           </a:p>
         </p:txBody>
       </p:sp>
@@ -5197,8 +5209,8 @@
         </p:nvSpPr>
         <p:spPr>
           <a:xfrm>
-            <a:off x="3291840" y="3429000"/>
-            <a:ext cx="2468880" cy="548640"/>
+            <a:off x="3246120" y="3383280"/>
+            <a:ext cx="2606040" cy="777240"/>
           </a:xfrm>
           <a:prstGeom prst="rect">
             <a:avLst/>
@@ -5214,14 +5226,14 @@
               <a:buNone/>
             </a:pPr>
             <a:r>
-              <a:rPr lang="en-US" sz="1200" dirty="0">
+              <a:rPr lang="en-US" sz="1500" dirty="0">
                 <a:solidFill>
                   <a:schemeClr val="bg2"/>
                 </a:solidFill>
               </a:rPr>
               <a:t>RA同士、寮母さん、大学が支えてくれます</a:t>
             </a:r>
-            <a:endParaRPr lang="en-US" sz="1200" dirty="0"/>
+            <a:endParaRPr lang="en-US" sz="1500" dirty="0"/>
           </a:p>
         </p:txBody>
       </p:sp>
@@ -5233,8 +5245,8 @@
         </p:nvSpPr>
         <p:spPr>
           <a:xfrm>
-            <a:off x="6035040" y="2331720"/>
-            <a:ext cx="548640" cy="548640"/>
+            <a:off x="6035040" y="2194560"/>
+            <a:ext cx="594360" cy="594360"/>
           </a:xfrm>
           <a:prstGeom prst="ellipse">
             <a:avLst/>
@@ -5266,8 +5278,8 @@
         </p:blipFill>
         <p:spPr>
           <a:xfrm>
-            <a:off x="6172200" y="2468880"/>
-            <a:ext cx="274320" cy="274320"/>
+            <a:off x="6181344" y="2340864"/>
+            <a:ext cx="301752" cy="301752"/>
           </a:xfrm>
           <a:prstGeom prst="rect">
             <a:avLst/>
@@ -5282,8 +5294,8 @@
         </p:nvSpPr>
         <p:spPr>
           <a:xfrm>
-            <a:off x="6035040" y="3017520"/>
-            <a:ext cx="2468880" cy="548640"/>
+            <a:off x="6035040" y="2926080"/>
+            <a:ext cx="2651760" cy="411480"/>
           </a:xfrm>
           <a:prstGeom prst="rect">
             <a:avLst/>
@@ -5299,14 +5311,14 @@
               <a:buNone/>
             </a:pPr>
             <a:r>
-              <a:rPr lang="en-US" sz="1400" b="1" dirty="0">
+              <a:rPr lang="en-US" sz="1900" b="1" dirty="0">
                 <a:solidFill>
                   <a:schemeClr val="bg1"/>
                 </a:solidFill>
               </a:rPr>
               <a:t>自分自身が成長できる</a:t>
             </a:r>
-            <a:endParaRPr lang="en-US" sz="1400" dirty="0"/>
+            <a:endParaRPr lang="en-US" sz="1900" dirty="0"/>
           </a:p>
         </p:txBody>
       </p:sp>
@@ -5318,8 +5330,8 @@
         </p:nvSpPr>
         <p:spPr>
           <a:xfrm>
-            <a:off x="6035040" y="3429000"/>
-            <a:ext cx="2468880" cy="548640"/>
+            <a:off x="6035040" y="3383280"/>
+            <a:ext cx="2606040" cy="777240"/>
           </a:xfrm>
           <a:prstGeom prst="rect">
             <a:avLst/>
@@ -5335,14 +5347,14 @@
               <a:buNone/>
             </a:pPr>
             <a:r>
-              <a:rPr lang="en-US" sz="1200" dirty="0">
+              <a:rPr lang="en-US" sz="1500" dirty="0">
                 <a:solidFill>
                   <a:schemeClr val="bg2"/>
                 </a:solidFill>
               </a:rPr>
               <a:t>ここでしかできない経験が、きっと将来に活きます</a:t>
             </a:r>
-            <a:endParaRPr lang="en-US" sz="1200" dirty="0"/>
+            <a:endParaRPr lang="en-US" sz="1500" dirty="0"/>
           </a:p>
         </p:txBody>
       </p:sp>
@@ -5354,8 +5366,8 @@
         </p:nvSpPr>
         <p:spPr>
           <a:xfrm>
-            <a:off x="548640" y="4389120"/>
-            <a:ext cx="8046720" cy="365760"/>
+            <a:off x="457200" y="4343400"/>
+            <a:ext cx="8229600" cy="457200"/>
           </a:xfrm>
           <a:prstGeom prst="rect">
             <a:avLst/>
@@ -5371,14 +5383,14 @@
               <a:buNone/>
             </a:pPr>
             <a:r>
-              <a:rPr lang="en-US" sz="1300" b="1" dirty="0">
+              <a:rPr lang="en-US" sz="1800" b="1" dirty="0">
                 <a:solidFill>
                   <a:schemeClr val="bg1"/>
                 </a:solidFill>
               </a:rPr>
-              <a:t>説明会のあと、個別のご相談にも対応します。気軽に声をかけてください！</a:t>
-            </a:r>
-            <a:endParaRPr lang="en-US" sz="1300" dirty="0"/>
+              <a:t>説明会のあと個別相談OK！ 気軽に声をかけてください</a:t>
+            </a:r>
+            <a:endParaRPr lang="en-US" sz="1800" dirty="0"/>
           </a:p>
         </p:txBody>
       </p:sp>

</xml_diff>

<commit_message>
Use descriptive alt text for photos in RA briefing deck
Co-Authored-By: Claude Opus 5.5 <noreply@anthropic.com>
Claude-Session: https://claude.ai/code/session_01LZtd5ZCaickQQtidZY1i9h
</commit_message>
<xml_diff>
--- a/RA募集説明会_RAプレゼン_20261023.pptx
+++ b/RA募集説明会_RAプレゼン_20261023.pptx
@@ -1549,7 +1549,7 @@
       </p:grpSpPr>
       <p:pic>
         <p:nvPicPr>
-          <p:cNvPr id="2" name="図 2" descr="/tmp/claude-0/-home-user--/df02d968-b5f5-5c15-93e8-b428a1ab583e/scratchpad/in/raz/ppt/media/image12.jpg">    </p:cNvPr>
+          <p:cNvPr id="2" name="図 2" descr="新入生歓迎会の様子">    </p:cNvPr>
           <p:cNvPicPr>
             <a:picLocks noChangeAspect="1"/>
           </p:cNvPicPr>
@@ -3163,7 +3163,7 @@
       </p:sp>
       <p:pic>
         <p:nvPicPr>
-          <p:cNvPr id="3" name="図 38" descr="/tmp/claude-0/-home-user--/df02d968-b5f5-5c15-93e8-b428a1ab583e/scratchpad/in/raz/ppt/media/image12.jpg">    </p:cNvPr>
+          <p:cNvPr id="3" name="図 38" descr="4月 新入生歓迎会の様子">    </p:cNvPr>
           <p:cNvPicPr>
             <a:picLocks noChangeAspect="1"/>
           </p:cNvPicPr>
@@ -3272,7 +3272,7 @@
       </p:sp>
       <p:pic>
         <p:nvPicPr>
-          <p:cNvPr id="6" name="図 41" descr="/tmp/claude-0/-home-user--/df02d968-b5f5-5c15-93e8-b428a1ab583e/scratchpad/in/raz/ppt/media/image16.jpg">    </p:cNvPr>
+          <p:cNvPr id="6" name="図 41" descr="5月 クリーン大作戦の様子">    </p:cNvPr>
           <p:cNvPicPr>
             <a:picLocks noChangeAspect="1"/>
           </p:cNvPicPr>

</xml_diff>

<commit_message>
Match closing slide colors to the rest of the RA deck
Co-Authored-By: Claude Opus 5.5 <noreply@anthropic.com>
Claude-Session: https://claude.ai/code/session_01LZtd5ZCaickQQtidZY1i9h
</commit_message>
<xml_diff>
--- a/RA募集説明会_RAプレゼン_20261023.pptx
+++ b/RA募集説明会_RAプレゼン_20261023.pptx
@@ -3841,14 +3841,52 @@
       </p:grpSpPr>
       <p:sp>
         <p:nvSpPr>
-          <p:cNvPr id="2" name="テキスト ボックス 51"/>
+          <p:cNvPr id="2" name="Text 0"/>
+          <p:cNvSpPr/>
+          <p:nvPr>
+            <p:ph idx="100" type="title" hasCustomPrompt="1"/>
+          </p:nvPr>
+        </p:nvSpPr>
+        <p:spPr>
+          <a:xfrm>
+            <a:off x="457200" y="274320"/>
+            <a:ext cx="8229600" cy="731520"/>
+          </a:xfrm>
+          <a:prstGeom prst="rect">
+            <a:avLst/>
+          </a:prstGeom>
+          <a:noFill/>
+          <a:ln/>
+        </p:spPr>
+        <p:txBody>
+          <a:bodyPr wrap="square" lIns="0" tIns="0" rIns="0" bIns="0" rtlCol="0" anchor="ctr"/>
+          <a:lstStyle/>
+          <a:p>
+            <a:pPr algn="l" indent="0" marL="0">
+              <a:buNone/>
+            </a:pPr>
+            <a:r>
+              <a:rPr lang="en-US" sz="3400" b="1" dirty="0">
+                <a:solidFill>
+                  <a:srgbClr val="1F3864"/>
+                </a:solidFill>
+              </a:rPr>
+              <a:t>最後に</a:t>
+            </a:r>
+            <a:endParaRPr lang="en-US" sz="3400" dirty="0"/>
+          </a:p>
+        </p:txBody>
+      </p:sp>
+      <p:sp>
+        <p:nvSpPr>
+          <p:cNvPr id="3" name="テキスト ボックス 51"/>
           <p:cNvSpPr txBox="1"/>
           <p:nvPr/>
         </p:nvSpPr>
         <p:spPr>
           <a:xfrm>
-            <a:off x="640080" y="548640"/>
-            <a:ext cx="7863840" cy="411480"/>
+            <a:off x="457200" y="1097280"/>
+            <a:ext cx="8229600" cy="1188720"/>
           </a:xfrm>
           <a:prstGeom prst="rect">
             <a:avLst/>
@@ -3864,27 +3902,61 @@
               <a:buNone/>
             </a:pPr>
             <a:r>
-              <a:rPr lang="en-US" sz="2000" b="1" dirty="0">
-                <a:solidFill>
-                  <a:srgbClr val="F4B183"/>
-                </a:solidFill>
-              </a:rPr>
-              <a:t>最後に</a:t>
-            </a:r>
-            <a:endParaRPr lang="en-US" sz="2000" dirty="0"/>
-          </a:p>
-        </p:txBody>
-      </p:sp>
-      <p:sp>
-        <p:nvSpPr>
-          <p:cNvPr id="3" name="テキスト ボックス 52"/>
+              <a:rPr lang="en-US" sz="3200" b="1" dirty="0">
+                <a:solidFill>
+                  <a:srgbClr val="1F3864"/>
+                </a:solidFill>
+              </a:rPr>
+              <a:t>少しでも興味があれば、</a:t>
+            </a:r>
+            <a:endParaRPr lang="en-US" sz="3200" dirty="0"/>
+          </a:p>
+          <a:p>
+            <a:pPr indent="0" marL="0">
+              <a:buNone/>
+            </a:pPr>
+            <a:r>
+              <a:rPr lang="en-US" sz="3200" b="1" dirty="0">
+                <a:solidFill>
+                  <a:srgbClr val="1F3864"/>
+                </a:solidFill>
+              </a:rPr>
+              <a:t>ぜひ応募してみてください</a:t>
+            </a:r>
+            <a:endParaRPr lang="en-US" sz="3200" dirty="0"/>
+          </a:p>
+        </p:txBody>
+      </p:sp>
+      <p:sp>
+        <p:nvSpPr>
+          <p:cNvPr id="4" name="正方形/長方形 52"/>
+          <p:cNvSpPr/>
+          <p:nvPr/>
+        </p:nvSpPr>
+        <p:spPr>
+          <a:xfrm>
+            <a:off x="457200" y="2468880"/>
+            <a:ext cx="8229600" cy="1600200"/>
+          </a:xfrm>
+          <a:prstGeom prst="rect">
+            <a:avLst/>
+          </a:prstGeom>
+          <a:solidFill>
+            <a:srgbClr val="DEEBF7"/>
+          </a:solidFill>
+          <a:ln/>
+        </p:spPr>
+      </p:sp>
+      <p:sp>
+        <p:nvSpPr>
+          <p:cNvPr id="5" name="テキスト ボックス 53"/>
           <p:cNvSpPr txBox="1"/>
           <p:nvPr/>
         </p:nvSpPr>
         <p:spPr>
           <a:xfrm>
-            <a:off x="640080" y="1005840"/>
-            <a:ext cx="7863840" cy="1325880"/>
+            <a:off x="731520" y="2468880"/>
+            <a:ext cx="7680960" cy="1600200"/>
           </a:xfrm>
           <a:prstGeom prst="rect">
             <a:avLst/>
@@ -3894,56 +3966,6 @@
         </p:spPr>
         <p:txBody>
           <a:bodyPr wrap="square" lIns="0" tIns="0" rIns="0" bIns="0" rtlCol="0" anchor="ctr"/>
-          <a:lstStyle/>
-          <a:p>
-            <a:pPr indent="0" marL="0">
-              <a:buNone/>
-            </a:pPr>
-            <a:r>
-              <a:rPr lang="en-US" sz="3600" b="1" dirty="0">
-                <a:solidFill>
-                  <a:srgbClr val="FFFFFF"/>
-                </a:solidFill>
-              </a:rPr>
-              <a:t>少しでも興味があれば、</a:t>
-            </a:r>
-            <a:endParaRPr lang="en-US" sz="3600" dirty="0"/>
-          </a:p>
-          <a:p>
-            <a:pPr indent="0" marL="0">
-              <a:buNone/>
-            </a:pPr>
-            <a:r>
-              <a:rPr lang="en-US" sz="3600" b="1" dirty="0">
-                <a:solidFill>
-                  <a:srgbClr val="FFFFFF"/>
-                </a:solidFill>
-              </a:rPr>
-              <a:t>ぜひ応募してみてください</a:t>
-            </a:r>
-            <a:endParaRPr lang="en-US" sz="3600" dirty="0"/>
-          </a:p>
-        </p:txBody>
-      </p:sp>
-      <p:sp>
-        <p:nvSpPr>
-          <p:cNvPr id="4" name="テキスト ボックス 53"/>
-          <p:cNvSpPr txBox="1"/>
-          <p:nvPr/>
-        </p:nvSpPr>
-        <p:spPr>
-          <a:xfrm>
-            <a:off x="640080" y="2606040"/>
-            <a:ext cx="7863840" cy="1417320"/>
-          </a:xfrm>
-          <a:prstGeom prst="rect">
-            <a:avLst/>
-          </a:prstGeom>
-          <a:noFill/>
-          <a:ln/>
-        </p:spPr>
-        <p:txBody>
-          <a:bodyPr wrap="square" lIns="0" tIns="0" rIns="0" bIns="0" rtlCol="0" anchor="t"/>
           <a:lstStyle/>
           <a:p>
             <a:pPr marL="203200" indent="-203200">
@@ -3956,7 +3978,7 @@
             <a:r>
               <a:rPr lang="en-US" sz="2200" dirty="0">
                 <a:solidFill>
-                  <a:srgbClr val="FFFFFF"/>
+                  <a:srgbClr val="262626"/>
                 </a:solidFill>
               </a:rPr>
               <a:t>特別なスキルや経験はいりません</a:t>
@@ -3974,7 +3996,7 @@
             <a:r>
               <a:rPr lang="en-US" sz="2200" dirty="0">
                 <a:solidFill>
-                  <a:srgbClr val="FFFFFF"/>
+                  <a:srgbClr val="262626"/>
                 </a:solidFill>
               </a:rPr>
               <a:t>わからないことは先輩RAがサポートします</a:t>
@@ -3992,7 +4014,7 @@
             <a:r>
               <a:rPr lang="en-US" sz="2200" dirty="0">
                 <a:solidFill>
-                  <a:srgbClr val="FFFFFF"/>
+                  <a:srgbClr val="262626"/>
                 </a:solidFill>
               </a:rPr>
               <a:t>このあと個別に質問も受け付けています</a:t>
@@ -4003,14 +4025,14 @@
       </p:sp>
       <p:sp>
         <p:nvSpPr>
-          <p:cNvPr id="5" name="テキスト ボックス 54"/>
+          <p:cNvPr id="6" name="テキスト ボックス 54"/>
           <p:cNvSpPr txBox="1"/>
           <p:nvPr/>
         </p:nvSpPr>
         <p:spPr>
           <a:xfrm>
-            <a:off x="640080" y="4251960"/>
-            <a:ext cx="7863840" cy="411480"/>
+            <a:off x="457200" y="4251960"/>
+            <a:ext cx="7589520" cy="411480"/>
           </a:xfrm>
           <a:prstGeom prst="rect">
             <a:avLst/>
@@ -4028,7 +4050,7 @@
             <a:r>
               <a:rPr lang="en-US" sz="1800" dirty="0">
                 <a:solidFill>
-                  <a:srgbClr val="D9D9D9"/>
+                  <a:srgbClr val="595959"/>
                 </a:solidFill>
               </a:rPr>
               <a:t>ご清聴ありがとうございました</a:t>
@@ -4039,31 +4061,46 @@
       </p:sp>
       <p:sp>
         <p:nvSpPr>
-          <p:cNvPr id="7" name="Text 0"/>
-          <p:cNvSpPr/>
+          <p:cNvPr id="25" name="Slide Number Placeholder 0"/>
+          <p:cNvSpPr>
+            <a:spLocks noGrp="1"/>
+          </p:cNvSpPr>
           <p:nvPr>
-            <p:ph idx="100" type="title" hasCustomPrompt="1"/>
+            <p:ph type="sldNum" sz="quarter" idx="4294967295"/>
           </p:nvPr>
         </p:nvSpPr>
         <p:spPr>
           <a:xfrm>
-            <a:off x="640080" y="1691640"/>
-            <a:ext cx="7863840" cy="914400"/>
-          </a:xfrm>
-          <a:prstGeom prst="rect">
-            <a:avLst/>
-          </a:prstGeom>
-          <a:noFill/>
-          <a:ln/>
-        </p:spPr>
-        <p:txBody>
-          <a:bodyPr wrap="square" lIns="0" tIns="0" rIns="0" bIns="0" rtlCol="0" anchor="ctr"/>
-          <a:lstStyle/>
-          <a:p>
-            <a:pPr algn="l" indent="0" marL="0">
-              <a:buNone/>
-            </a:pPr>
-            <a:endParaRPr lang="en-US" sz="5400" dirty="0"/>
+            <a:off x="8138160" y="4754880"/>
+            <a:ext cx="548640" cy="274320"/>
+          </a:xfrm>
+          <a:prstGeom prst="rect">
+            <a:avLst/>
+          </a:prstGeom>
+          <a:extLst>
+            <a:ext uri="{C572A759-6A51-4108-AA02-DFA0A04FC94B}">
+              <ma14:wrappingTextBoxFlag xmlns:ma14="http://schemas.microsoft.com/office/mac/drawingml/2011/main" val="0"/>
+            </a:ext>
+          </a:extLst>
+        </p:spPr>
+        <p:txBody>
+          <a:bodyPr/>
+          <a:lstStyle>
+            <a:lvl1pPr>
+              <a:defRPr sz="1200">
+                <a:solidFill>
+                  <a:srgbClr val="595959"/>
+                </a:solidFill>
+              </a:defRPr>
+            </a:lvl1pPr>
+          </a:lstStyle>
+          <a:p>
+            <a:pPr algn="r"/>
+            <a:fld id="{F7021451-1387-4CA6-816F-3879F97B5CBC}" type="slidenum">
+              <a:rPr b="0" lang="en-US"/>
+              <a:t>6</a:t>
+            </a:fld>
+            <a:endParaRPr lang="en-US"/>
           </a:p>
         </p:txBody>
       </p:sp>

</xml_diff>